<commit_message>
Portada sin la línea 'Preparado por'
Co-Authored-By: Claude Opus 5.5 <noreply@anthropic.com>
Claude-Session: https://claude.ai/code/session_01RrEJtrwRidXxzgveZEVQjf
</commit_message>
<xml_diff>
--- a/presentaciones/Plan_Estrategico_Electoral_Pennsylvania_2028.pptx
+++ b/presentaciones/Plan_Estrategico_Electoral_Pennsylvania_2028.pptx
@@ -116,7 +116,7 @@
   <p:extLst>
     <p:ext uri="{521415D9-36F7-43E2-AB2F-B90AF26B5E84}">
       <p14:sectionLst xmlns:p14="http://schemas.microsoft.com/office/powerpoint/2010/main">
-        <p14:section name="Diagnóstico" id="{149d7052-b90d-c4b0-9541-693a631c2abd}">
+        <p14:section name="Diagnóstico" id="{81055105-8a35-dbeb-b116-b418d11f6653}">
           <p14:sldIdLst>
             <p14:sldId id="256"/>
             <p14:sldId id="257"/>
@@ -124,24 +124,24 @@
             <p14:sldId id="259"/>
           </p14:sldIdLst>
         </p14:section>
-        <p14:section name="Resultados 2024" id="{68759f9d-ffb6-f557-aa94-9564408c786d}">
+        <p14:section name="Resultados 2024" id="{c0a13815-683a-a0ae-04e2-1fed2887444b}">
           <p14:sldIdLst>
             <p14:sldId id="260"/>
           </p14:sldIdLst>
         </p14:section>
-        <p14:section name="Meta" id="{c9fa0979-683e-bf98-fec2-c110fe7253f7}">
+        <p14:section name="Meta" id="{7b4351ed-713f-d7b1-1df9-e65905ad782b}">
           <p14:sldIdLst>
             <p14:sldId id="261"/>
           </p14:sldIdLst>
         </p14:section>
-        <p14:section name="Plan y recomendación" id="{6274a623-48da-2918-6de2-e34c994f86c0}">
+        <p14:section name="Plan y recomendación" id="{4668df20-0698-8355-8f01-343e1e10e704}">
           <p14:sldIdLst>
             <p14:sldId id="262"/>
             <p14:sldId id="263"/>
             <p14:sldId id="264"/>
           </p14:sldIdLst>
         </p14:section>
-        <p14:section name="Ficha técnica" id="{efbde180-4e54-83e7-8fe6-36d78e6c2531}">
+        <p14:section name="Ficha técnica" id="{b1733dec-3d2c-ae73-c2a1-e67bb84fa3df}">
           <p14:sldIdLst>
             <p14:sldId id="265"/>
           </p14:sldIdLst>
@@ -2870,20 +2870,6 @@
                 </a:solidFill>
               </a:rPr>
               <a:t>Plan Estratégico Electoral Pennsylvania 2028</a:t>
-            </a:r>
-            <a:endParaRPr lang="en-US" sz="2400" dirty="0"/>
-          </a:p>
-          <a:p>
-            <a:pPr indent="0" marL="0">
-              <a:buNone/>
-            </a:pPr>
-            <a:r>
-              <a:rPr lang="en-US" sz="1500" dirty="0">
-                <a:solidFill>
-                  <a:schemeClr val="accent4"/>
-                </a:solidFill>
-              </a:rPr>
-              <a:t>Preparado por Orlando Castillo</a:t>
             </a:r>
             <a:endParaRPr lang="en-US" sz="2400" dirty="0"/>
           </a:p>

</xml_diff>

<commit_message>
Portada: destacar 'Propuesta para el CAD'
Co-Authored-By: Claude Opus 5.5 <noreply@anthropic.com>
Claude-Session: https://claude.ai/code/session_01RrEJtrwRidXxzgveZEVQjf
</commit_message>
<xml_diff>
--- a/presentaciones/Plan_Estrategico_Electoral_Pennsylvania_2028.pptx
+++ b/presentaciones/Plan_Estrategico_Electoral_Pennsylvania_2028.pptx
@@ -116,7 +116,7 @@
   <p:extLst>
     <p:ext uri="{521415D9-36F7-43E2-AB2F-B90AF26B5E84}">
       <p14:sectionLst xmlns:p14="http://schemas.microsoft.com/office/powerpoint/2010/main">
-        <p14:section name="Diagnóstico" id="{81055105-8a35-dbeb-b116-b418d11f6653}">
+        <p14:section name="Diagnóstico" id="{dc4530c1-f33c-7ca7-96dc-5ae8257b8bdc}">
           <p14:sldIdLst>
             <p14:sldId id="256"/>
             <p14:sldId id="257"/>
@@ -124,24 +124,24 @@
             <p14:sldId id="259"/>
           </p14:sldIdLst>
         </p14:section>
-        <p14:section name="Resultados 2024" id="{c0a13815-683a-a0ae-04e2-1fed2887444b}">
+        <p14:section name="Resultados 2024" id="{4f942f63-a69f-0616-f2b7-1c4fb9eb66ea}">
           <p14:sldIdLst>
             <p14:sldId id="260"/>
           </p14:sldIdLst>
         </p14:section>
-        <p14:section name="Meta" id="{7b4351ed-713f-d7b1-1df9-e65905ad782b}">
+        <p14:section name="Meta" id="{f8c03de9-1c38-0843-70c9-f11b35b86e9b}">
           <p14:sldIdLst>
             <p14:sldId id="261"/>
           </p14:sldIdLst>
         </p14:section>
-        <p14:section name="Plan y recomendación" id="{4668df20-0698-8355-8f01-343e1e10e704}">
+        <p14:section name="Plan y recomendación" id="{af15c207-e951-1819-893e-264ceaf381d9}">
           <p14:sldIdLst>
             <p14:sldId id="262"/>
             <p14:sldId id="263"/>
             <p14:sldId id="264"/>
           </p14:sldIdLst>
         </p14:section>
-        <p14:section name="Ficha técnica" id="{b1733dec-3d2c-ae73-c2a1-e67bb84fa3df}">
+        <p14:section name="Ficha técnica" id="{7bba8224-39b0-c1c7-aeef-6330143d5472}">
           <p14:sldIdLst>
             <p14:sldId id="265"/>
           </p14:sldIdLst>
@@ -2926,14 +2926,41 @@
       </p:pic>
       <p:sp>
         <p:nvSpPr>
-          <p:cNvPr id="5" name="Text 2"/>
+          <p:cNvPr id="5" name="Etiqueta propuesta"/>
+          <p:cNvSpPr/>
+          <p:nvPr/>
+        </p:nvSpPr>
+        <p:spPr>
+          <a:xfrm>
+            <a:off x="548640" y="1810512"/>
+            <a:ext cx="5943600" cy="457200"/>
+          </a:xfrm>
+          <a:prstGeom prst="roundRect">
+            <a:avLst>
+              <a:gd name="adj" fmla="val 50000"/>
+            </a:avLst>
+          </a:prstGeom>
+          <a:solidFill>
+            <a:schemeClr val="accent2"/>
+          </a:solidFill>
+          <a:ln w="12700">
+            <a:solidFill>
+              <a:schemeClr val="accent2"/>
+            </a:solidFill>
+            <a:prstDash val="solid"/>
+          </a:ln>
+        </p:spPr>
+      </p:sp>
+      <p:sp>
+        <p:nvSpPr>
+          <p:cNvPr id="6" name="Text 3"/>
           <p:cNvSpPr txBox="1"/>
           <p:nvPr/>
         </p:nvSpPr>
         <p:spPr>
           <a:xfrm>
-            <a:off x="548640" y="2057400"/>
-            <a:ext cx="7315200" cy="320040"/>
+            <a:off x="548640" y="1810512"/>
+            <a:ext cx="5943600" cy="457200"/>
           </a:xfrm>
           <a:prstGeom prst="rect">
             <a:avLst/>
@@ -2945,24 +2972,35 @@
           <a:bodyPr wrap="square" lIns="0" tIns="0" rIns="0" bIns="0" rtlCol="0" anchor="ctr"/>
           <a:lstStyle/>
           <a:p>
-            <a:pPr indent="0" marL="0">
-              <a:buNone/>
-            </a:pPr>
-            <a:r>
-              <a:rPr lang="en-US" sz="1300" b="1" spc="100" kern="0" dirty="0">
-                <a:solidFill>
-                  <a:schemeClr val="accent4"/>
-                </a:solidFill>
-              </a:rPr>
-              <a:t>PROPUESTA PARA EL CAD · SECCIONAL PENNSYLVANIA</a:t>
-            </a:r>
-            <a:endParaRPr lang="en-US" sz="1300" dirty="0"/>
-          </a:p>
-        </p:txBody>
-      </p:sp>
-      <p:sp>
-        <p:nvSpPr>
-          <p:cNvPr id="6" name="Titulo"/>
+            <a:pPr algn="ctr" indent="0" marL="0">
+              <a:buNone/>
+            </a:pPr>
+            <a:r>
+              <a:rPr lang="en-US" sz="1600" b="1" spc="100" kern="0" dirty="0">
+                <a:solidFill>
+                  <a:schemeClr val="bg1"/>
+                </a:solidFill>
+              </a:rPr>
+              <a:t>PROPUESTA PARA EL CAD</a:t>
+            </a:r>
+            <a:pPr algn="ctr" indent="0" marL="0">
+              <a:buNone/>
+            </a:pPr>
+            <a:r>
+              <a:rPr lang="en-US" sz="1600" spc="100" kern="0" dirty="0">
+                <a:solidFill>
+                  <a:srgbClr val="FFD9DB"/>
+                </a:solidFill>
+              </a:rPr>
+              <a:t>  ·  SECCIONAL PENNSYLVANIA</a:t>
+            </a:r>
+            <a:endParaRPr lang="en-US" sz="1600" dirty="0"/>
+          </a:p>
+        </p:txBody>
+      </p:sp>
+      <p:sp>
+        <p:nvSpPr>
+          <p:cNvPr id="7" name="Titulo"/>
           <p:cNvSpPr txBox="1"/>
           <p:nvPr/>
         </p:nvSpPr>
@@ -3001,7 +3039,7 @@
       </p:sp>
       <p:graphicFrame>
         <p:nvGraphicFramePr>
-          <p:cNvPr id="7" name="Participacion" descr=""/>
+          <p:cNvPr id="8" name="Participacion" descr=""/>
           <p:cNvGraphicFramePr/>
           <p:nvPr/>
         </p:nvGraphicFramePr>
@@ -3017,7 +3055,7 @@
       </p:graphicFrame>
       <p:sp>
         <p:nvSpPr>
-          <p:cNvPr id="8" name="Text 4"/>
+          <p:cNvPr id="9" name="Text 5"/>
           <p:cNvSpPr txBox="1"/>
           <p:nvPr/>
         </p:nvSpPr>
@@ -3067,7 +3105,7 @@
       </p:sp>
       <p:sp>
         <p:nvSpPr>
-          <p:cNvPr id="9" name="Dato 1"/>
+          <p:cNvPr id="10" name="Dato 1"/>
           <p:cNvSpPr/>
           <p:nvPr/>
         </p:nvSpPr>
@@ -3098,7 +3136,7 @@
       </p:sp>
       <p:sp>
         <p:nvSpPr>
-          <p:cNvPr id="10" name="Text 6"/>
+          <p:cNvPr id="11" name="Text 7"/>
           <p:cNvSpPr txBox="1"/>
           <p:nvPr/>
         </p:nvSpPr>
@@ -3148,7 +3186,7 @@
       </p:sp>
       <p:sp>
         <p:nvSpPr>
-          <p:cNvPr id="11" name="Dato 2"/>
+          <p:cNvPr id="12" name="Dato 2"/>
           <p:cNvSpPr/>
           <p:nvPr/>
         </p:nvSpPr>
@@ -3179,7 +3217,7 @@
       </p:sp>
       <p:sp>
         <p:nvSpPr>
-          <p:cNvPr id="12" name="Text 8"/>
+          <p:cNvPr id="13" name="Text 9"/>
           <p:cNvSpPr txBox="1"/>
           <p:nvPr/>
         </p:nvSpPr>
@@ -3229,7 +3267,7 @@
       </p:sp>
       <p:sp>
         <p:nvSpPr>
-          <p:cNvPr id="13" name="Dato 3"/>
+          <p:cNvPr id="14" name="Dato 3"/>
           <p:cNvSpPr/>
           <p:nvPr/>
         </p:nvSpPr>
@@ -3260,7 +3298,7 @@
       </p:sp>
       <p:sp>
         <p:nvSpPr>
-          <p:cNvPr id="14" name="Text 10"/>
+          <p:cNvPr id="15" name="Text 11"/>
           <p:cNvSpPr txBox="1"/>
           <p:nvPr/>
         </p:nvSpPr>
@@ -3310,7 +3348,7 @@
       </p:sp>
       <p:sp>
         <p:nvSpPr>
-          <p:cNvPr id="15" name="Dato 4"/>
+          <p:cNvPr id="16" name="Dato 4"/>
           <p:cNvSpPr/>
           <p:nvPr/>
         </p:nvSpPr>
@@ -3341,7 +3379,7 @@
       </p:sp>
       <p:sp>
         <p:nvSpPr>
-          <p:cNvPr id="16" name="Text 12"/>
+          <p:cNvPr id="17" name="Text 13"/>
           <p:cNvSpPr txBox="1"/>
           <p:nvPr/>
         </p:nvSpPr>
@@ -3391,7 +3429,7 @@
       </p:sp>
       <p:sp>
         <p:nvSpPr>
-          <p:cNvPr id="17" name="Text 13"/>
+          <p:cNvPr id="18" name="Text 14"/>
           <p:cNvSpPr txBox="1"/>
           <p:nvPr/>
         </p:nvSpPr>
@@ -3427,7 +3465,7 @@
       </p:sp>
       <p:sp>
         <p:nvSpPr>
-          <p:cNvPr id="19" name="Barra de navegación"/>
+          <p:cNvPr id="20" name="Barra de navegación"/>
           <p:cNvSpPr/>
           <p:nvPr/>
         </p:nvSpPr>
@@ -3452,7 +3490,7 @@
       </p:sp>
       <p:sp>
         <p:nvSpPr>
-          <p:cNvPr id="20" name="Shape 15"/>
+          <p:cNvPr id="21" name="Shape 16"/>
           <p:cNvSpPr/>
           <p:nvPr/>
         </p:nvSpPr>
@@ -3475,7 +3513,7 @@
       </p:sp>
       <p:sp>
         <p:nvSpPr>
-          <p:cNvPr id="21" name="Pestaña Diagnóstico"/>
+          <p:cNvPr id="22" name="Pestaña Diagnóstico"/>
           <p:cNvSpPr txBox="1"/>
           <p:nvPr/>
         </p:nvSpPr>
@@ -3511,7 +3549,7 @@
       </p:sp>
       <p:sp>
         <p:nvSpPr>
-          <p:cNvPr id="22" name="Sección actual"/>
+          <p:cNvPr id="23" name="Sección actual"/>
           <p:cNvSpPr/>
           <p:nvPr/>
         </p:nvSpPr>
@@ -3536,7 +3574,7 @@
       </p:sp>
       <p:sp>
         <p:nvSpPr>
-          <p:cNvPr id="23" name="Pestaña Resultados 2024"/>
+          <p:cNvPr id="24" name="Pestaña Resultados 2024"/>
           <p:cNvSpPr txBox="1"/>
           <p:nvPr/>
         </p:nvSpPr>
@@ -3579,7 +3617,7 @@
       </p:sp>
       <p:sp>
         <p:nvSpPr>
-          <p:cNvPr id="24" name="Pestaña Meta"/>
+          <p:cNvPr id="25" name="Pestaña Meta"/>
           <p:cNvSpPr txBox="1"/>
           <p:nvPr/>
         </p:nvSpPr>
@@ -3622,7 +3660,7 @@
       </p:sp>
       <p:sp>
         <p:nvSpPr>
-          <p:cNvPr id="25" name="Pestaña Plan y recomendación"/>
+          <p:cNvPr id="26" name="Pestaña Plan y recomendación"/>
           <p:cNvSpPr txBox="1"/>
           <p:nvPr/>
         </p:nvSpPr>
@@ -3665,7 +3703,7 @@
       </p:sp>
       <p:sp>
         <p:nvSpPr>
-          <p:cNvPr id="26" name="Pestaña Ficha técnica"/>
+          <p:cNvPr id="27" name="Pestaña Ficha técnica"/>
           <p:cNvSpPr txBox="1"/>
           <p:nvPr/>
         </p:nvSpPr>

</xml_diff>

<commit_message>
Agrega marca de agua «Confidencial · Uso interno del CAD» al plan (PPTX, PDF y web)
Co-Authored-By: Claude Opus 5.5 <noreply@anthropic.com>
Claude-Session: https://claude.ai/code/session_01RrEJtrwRidXxzgveZEVQjf
</commit_message>
<xml_diff>
--- a/presentaciones/Plan_Estrategico_Electoral_Pennsylvania_2028.pptx
+++ b/presentaciones/Plan_Estrategico_Electoral_Pennsylvania_2028.pptx
@@ -115,19 +115,19 @@
   <p:extLst>
     <p:ext uri="{521415D9-36F7-43E2-AB2F-B90AF26B5E84}">
       <p14:sectionLst xmlns:p14="http://schemas.microsoft.com/office/powerpoint/2010/main">
-        <p14:section name="Diagnóstico" id="{8c9881e3-8d15-f8be-615e-5d2c47e75dab}">
+        <p14:section name="Diagnóstico" id="{d23820ea-5169-ae62-a496-a2245df8f1b9}">
           <p14:sldIdLst>
             <p14:sldId id="256"/>
             <p14:sldId id="257"/>
             <p14:sldId id="258"/>
           </p14:sldIdLst>
         </p14:section>
-        <p14:section name="Meta" id="{0f4086a3-c126-e5d1-3298-3cd789b586ef}">
+        <p14:section name="Meta" id="{fb9bcf24-d6dd-faf0-b022-0cd9b7ce23a0}">
           <p14:sldIdLst>
             <p14:sldId id="259"/>
           </p14:sldIdLst>
         </p14:section>
-        <p14:section name="Plan y recomendación" id="{a3da7307-9e51-1447-e27b-c948bc7ec71f}">
+        <p14:section name="Plan y recomendación" id="{e65f8ddf-a990-3898-c37e-4bb2110ce87f}">
           <p14:sldIdLst>
             <p14:sldId id="260"/>
             <p14:sldId id="261"/>
@@ -135,7 +135,7 @@
             <p14:sldId id="263"/>
           </p14:sldIdLst>
         </p14:section>
-        <p14:section name="Ficha técnica" id="{2d532819-8081-8ea1-25e8-5e279d7101c9}">
+        <p14:section name="Ficha técnica" id="{417704cb-7c17-9122-959b-186ddcfa4640}">
           <p14:sldIdLst>
             <p14:sldId id="264"/>
           </p14:sldIdLst>
@@ -2747,7 +2747,45 @@
       </p:grpSpPr>
       <p:sp>
         <p:nvSpPr>
-          <p:cNvPr id="2" name="Autor"/>
+          <p:cNvPr id="2" name="Marca de agua"/>
+          <p:cNvSpPr txBox="1"/>
+          <p:nvPr/>
+        </p:nvSpPr>
+        <p:spPr>
+          <a:xfrm rot="-1200000">
+            <a:off x="-320040" y="2743200"/>
+            <a:ext cx="12801600" cy="1097280"/>
+          </a:xfrm>
+          <a:prstGeom prst="rect">
+            <a:avLst/>
+          </a:prstGeom>
+          <a:noFill/>
+          <a:ln/>
+        </p:spPr>
+        <p:txBody>
+          <a:bodyPr wrap="none" lIns="0" tIns="0" rIns="0" bIns="0" rtlCol="0" anchor="ctr"/>
+          <a:lstStyle/>
+          <a:p>
+            <a:pPr algn="ctr" indent="0" marL="0">
+              <a:buNone/>
+            </a:pPr>
+            <a:r>
+              <a:rPr lang="en-US" sz="4400" b="1" spc="200" kern="0" dirty="0">
+                <a:solidFill>
+                  <a:srgbClr val="FFFFFF">
+                    <a:alpha val="10000"/>
+                  </a:srgbClr>
+                </a:solidFill>
+              </a:rPr>
+              <a:t>CONFIDENCIAL · USO INTERNO DEL CAD</a:t>
+            </a:r>
+            <a:endParaRPr lang="en-US" sz="4400" dirty="0"/>
+          </a:p>
+        </p:txBody>
+      </p:sp>
+      <p:sp>
+        <p:nvSpPr>
+          <p:cNvPr id="3" name="Autor"/>
           <p:cNvSpPr txBox="1"/>
           <p:nvPr/>
         </p:nvSpPr>
@@ -2783,7 +2821,7 @@
       </p:sp>
       <p:sp>
         <p:nvSpPr>
-          <p:cNvPr id="3" name="Marco foto"/>
+          <p:cNvPr id="4" name="Marco foto"/>
           <p:cNvSpPr/>
           <p:nvPr/>
         </p:nvSpPr>
@@ -2808,7 +2846,7 @@
       </p:sp>
       <p:pic>
         <p:nvPicPr>
-          <p:cNvPr id="4" name="Foto Orlando Castillo" descr="Orlando Castillo">    </p:cNvPr>
+          <p:cNvPr id="5" name="Foto Orlando Castillo" descr="Orlando Castillo">    </p:cNvPr>
           <p:cNvPicPr>
             <a:picLocks noChangeAspect="1"/>
           </p:cNvPicPr>
@@ -2832,7 +2870,7 @@
       </p:pic>
       <p:sp>
         <p:nvSpPr>
-          <p:cNvPr id="5" name="Etiqueta propuesta"/>
+          <p:cNvPr id="6" name="Etiqueta propuesta"/>
           <p:cNvSpPr/>
           <p:nvPr/>
         </p:nvSpPr>
@@ -2859,7 +2897,7 @@
       </p:sp>
       <p:sp>
         <p:nvSpPr>
-          <p:cNvPr id="6" name="Text 3"/>
+          <p:cNvPr id="7" name="Text 4"/>
           <p:cNvSpPr txBox="1"/>
           <p:nvPr/>
         </p:nvSpPr>
@@ -2906,7 +2944,7 @@
       </p:sp>
       <p:sp>
         <p:nvSpPr>
-          <p:cNvPr id="7" name="Titulo"/>
+          <p:cNvPr id="8" name="Titulo"/>
           <p:cNvSpPr txBox="1"/>
           <p:nvPr/>
         </p:nvSpPr>
@@ -2945,7 +2983,7 @@
       </p:sp>
       <p:graphicFrame>
         <p:nvGraphicFramePr>
-          <p:cNvPr id="8" name="Participacion" descr=""/>
+          <p:cNvPr id="9" name="Participacion" descr=""/>
           <p:cNvGraphicFramePr/>
           <p:nvPr/>
         </p:nvGraphicFramePr>
@@ -2961,7 +2999,7 @@
       </p:graphicFrame>
       <p:sp>
         <p:nvSpPr>
-          <p:cNvPr id="9" name="Text 5"/>
+          <p:cNvPr id="10" name="Text 6"/>
           <p:cNvSpPr txBox="1"/>
           <p:nvPr/>
         </p:nvSpPr>
@@ -3011,7 +3049,7 @@
       </p:sp>
       <p:sp>
         <p:nvSpPr>
-          <p:cNvPr id="10" name="Dato 1"/>
+          <p:cNvPr id="11" name="Dato 1"/>
           <p:cNvSpPr/>
           <p:nvPr/>
         </p:nvSpPr>
@@ -3042,7 +3080,7 @@
       </p:sp>
       <p:sp>
         <p:nvSpPr>
-          <p:cNvPr id="11" name="Text 7"/>
+          <p:cNvPr id="12" name="Text 8"/>
           <p:cNvSpPr txBox="1"/>
           <p:nvPr/>
         </p:nvSpPr>
@@ -3092,7 +3130,7 @@
       </p:sp>
       <p:sp>
         <p:nvSpPr>
-          <p:cNvPr id="12" name="Dato 2"/>
+          <p:cNvPr id="13" name="Dato 2"/>
           <p:cNvSpPr/>
           <p:nvPr/>
         </p:nvSpPr>
@@ -3123,7 +3161,7 @@
       </p:sp>
       <p:sp>
         <p:nvSpPr>
-          <p:cNvPr id="13" name="Text 9"/>
+          <p:cNvPr id="14" name="Text 10"/>
           <p:cNvSpPr txBox="1"/>
           <p:nvPr/>
         </p:nvSpPr>
@@ -3173,7 +3211,7 @@
       </p:sp>
       <p:sp>
         <p:nvSpPr>
-          <p:cNvPr id="14" name="Dato 3"/>
+          <p:cNvPr id="15" name="Dato 3"/>
           <p:cNvSpPr/>
           <p:nvPr/>
         </p:nvSpPr>
@@ -3204,7 +3242,7 @@
       </p:sp>
       <p:sp>
         <p:nvSpPr>
-          <p:cNvPr id="15" name="Text 11"/>
+          <p:cNvPr id="16" name="Text 12"/>
           <p:cNvSpPr txBox="1"/>
           <p:nvPr/>
         </p:nvSpPr>
@@ -3254,7 +3292,7 @@
       </p:sp>
       <p:sp>
         <p:nvSpPr>
-          <p:cNvPr id="16" name="Dato 4"/>
+          <p:cNvPr id="17" name="Dato 4"/>
           <p:cNvSpPr/>
           <p:nvPr/>
         </p:nvSpPr>
@@ -3285,7 +3323,7 @@
       </p:sp>
       <p:sp>
         <p:nvSpPr>
-          <p:cNvPr id="17" name="Text 13"/>
+          <p:cNvPr id="18" name="Text 14"/>
           <p:cNvSpPr txBox="1"/>
           <p:nvPr/>
         </p:nvSpPr>
@@ -3335,7 +3373,7 @@
       </p:sp>
       <p:sp>
         <p:nvSpPr>
-          <p:cNvPr id="18" name="Text 14"/>
+          <p:cNvPr id="19" name="Text 15"/>
           <p:cNvSpPr txBox="1"/>
           <p:nvPr/>
         </p:nvSpPr>
@@ -3371,7 +3409,7 @@
       </p:sp>
       <p:sp>
         <p:nvSpPr>
-          <p:cNvPr id="20" name="Barra de navegación"/>
+          <p:cNvPr id="21" name="Barra de navegación"/>
           <p:cNvSpPr/>
           <p:nvPr/>
         </p:nvSpPr>
@@ -3396,7 +3434,7 @@
       </p:sp>
       <p:sp>
         <p:nvSpPr>
-          <p:cNvPr id="21" name="Shape 16"/>
+          <p:cNvPr id="22" name="Shape 17"/>
           <p:cNvSpPr/>
           <p:nvPr/>
         </p:nvSpPr>
@@ -3419,7 +3457,7 @@
       </p:sp>
       <p:sp>
         <p:nvSpPr>
-          <p:cNvPr id="22" name="Pestaña Diagnóstico"/>
+          <p:cNvPr id="23" name="Pestaña Diagnóstico"/>
           <p:cNvSpPr txBox="1"/>
           <p:nvPr/>
         </p:nvSpPr>
@@ -3455,7 +3493,7 @@
       </p:sp>
       <p:sp>
         <p:nvSpPr>
-          <p:cNvPr id="23" name="Sección actual"/>
+          <p:cNvPr id="24" name="Sección actual"/>
           <p:cNvSpPr/>
           <p:nvPr/>
         </p:nvSpPr>
@@ -3480,7 +3518,7 @@
       </p:sp>
       <p:sp>
         <p:nvSpPr>
-          <p:cNvPr id="24" name="Pestaña Meta"/>
+          <p:cNvPr id="25" name="Pestaña Meta"/>
           <p:cNvSpPr txBox="1"/>
           <p:nvPr/>
         </p:nvSpPr>
@@ -3523,7 +3561,7 @@
       </p:sp>
       <p:sp>
         <p:nvSpPr>
-          <p:cNvPr id="25" name="Pestaña Plan y recomendación"/>
+          <p:cNvPr id="26" name="Pestaña Plan y recomendación"/>
           <p:cNvSpPr txBox="1"/>
           <p:nvPr/>
         </p:nvSpPr>
@@ -3566,7 +3604,7 @@
       </p:sp>
       <p:sp>
         <p:nvSpPr>
-          <p:cNvPr id="26" name="Pestaña Ficha técnica"/>
+          <p:cNvPr id="27" name="Pestaña Ficha técnica"/>
           <p:cNvSpPr txBox="1"/>
           <p:nvPr/>
         </p:nvSpPr>
@@ -3679,7 +3717,45 @@
       </p:grpSpPr>
       <p:sp>
         <p:nvSpPr>
-          <p:cNvPr id="2" name="Text 1"/>
+          <p:cNvPr id="2" name="Marca de agua"/>
+          <p:cNvSpPr txBox="1"/>
+          <p:nvPr/>
+        </p:nvSpPr>
+        <p:spPr>
+          <a:xfrm rot="-1200000">
+            <a:off x="-320040" y="2743200"/>
+            <a:ext cx="12801600" cy="1097280"/>
+          </a:xfrm>
+          <a:prstGeom prst="rect">
+            <a:avLst/>
+          </a:prstGeom>
+          <a:noFill/>
+          <a:ln/>
+        </p:spPr>
+        <p:txBody>
+          <a:bodyPr wrap="none" lIns="0" tIns="0" rIns="0" bIns="0" rtlCol="0" anchor="ctr"/>
+          <a:lstStyle/>
+          <a:p>
+            <a:pPr algn="ctr" indent="0" marL="0">
+              <a:buNone/>
+            </a:pPr>
+            <a:r>
+              <a:rPr lang="en-US" sz="4400" b="1" spc="200" kern="0" dirty="0">
+                <a:solidFill>
+                  <a:srgbClr val="002B63">
+                    <a:alpha val="8000"/>
+                  </a:srgbClr>
+                </a:solidFill>
+              </a:rPr>
+              <a:t>CONFIDENCIAL · USO INTERNO DEL CAD</a:t>
+            </a:r>
+            <a:endParaRPr lang="en-US" sz="4400" dirty="0"/>
+          </a:p>
+        </p:txBody>
+      </p:sp>
+      <p:sp>
+        <p:nvSpPr>
+          <p:cNvPr id="3" name="Text 1"/>
           <p:cNvSpPr/>
           <p:nvPr>
             <p:ph idx="101" type="title" hasCustomPrompt="1"/>
@@ -3717,7 +3793,7 @@
       </p:sp>
       <p:graphicFrame>
         <p:nvGraphicFramePr>
-          <p:cNvPr id="3" name="Crecimiento poblacion" descr=""/>
+          <p:cNvPr id="4" name="Crecimiento poblacion" descr=""/>
           <p:cNvGraphicFramePr/>
           <p:nvPr/>
         </p:nvGraphicFramePr>
@@ -3733,7 +3809,7 @@
       </p:graphicFrame>
       <p:sp>
         <p:nvSpPr>
-          <p:cNvPr id="4" name="Oportunidad 1"/>
+          <p:cNvPr id="5" name="Oportunidad 1"/>
           <p:cNvSpPr/>
           <p:nvPr/>
         </p:nvSpPr>
@@ -3760,7 +3836,7 @@
       </p:sp>
       <p:sp>
         <p:nvSpPr>
-          <p:cNvPr id="5" name="Text 2"/>
+          <p:cNvPr id="6" name="Text 3"/>
           <p:cNvSpPr txBox="1"/>
           <p:nvPr/>
         </p:nvSpPr>
@@ -3810,7 +3886,7 @@
       </p:sp>
       <p:sp>
         <p:nvSpPr>
-          <p:cNvPr id="6" name="Oportunidad 2"/>
+          <p:cNvPr id="7" name="Oportunidad 2"/>
           <p:cNvSpPr/>
           <p:nvPr/>
         </p:nvSpPr>
@@ -3837,7 +3913,7 @@
       </p:sp>
       <p:sp>
         <p:nvSpPr>
-          <p:cNvPr id="7" name="Text 4"/>
+          <p:cNvPr id="8" name="Text 5"/>
           <p:cNvSpPr txBox="1"/>
           <p:nvPr/>
         </p:nvSpPr>
@@ -3887,7 +3963,7 @@
       </p:sp>
       <p:sp>
         <p:nvSpPr>
-          <p:cNvPr id="8" name="Dos tramites"/>
+          <p:cNvPr id="9" name="Dos tramites"/>
           <p:cNvSpPr/>
           <p:nvPr/>
         </p:nvSpPr>
@@ -3914,7 +3990,7 @@
       </p:sp>
       <p:sp>
         <p:nvSpPr>
-          <p:cNvPr id="9" name="Text 6"/>
+          <p:cNvPr id="10" name="Text 7"/>
           <p:cNvSpPr txBox="1"/>
           <p:nvPr/>
         </p:nvSpPr>
@@ -3964,7 +4040,7 @@
       </p:sp>
       <p:sp>
         <p:nvSpPr>
-          <p:cNvPr id="10" name="Fuente"/>
+          <p:cNvPr id="11" name="Fuente"/>
           <p:cNvSpPr txBox="1"/>
           <p:nvPr/>
         </p:nvSpPr>
@@ -4000,7 +4076,7 @@
       </p:sp>
       <p:sp>
         <p:nvSpPr>
-          <p:cNvPr id="12" name="Barra de navegación"/>
+          <p:cNvPr id="13" name="Barra de navegación"/>
           <p:cNvSpPr/>
           <p:nvPr/>
         </p:nvSpPr>
@@ -4025,7 +4101,7 @@
       </p:sp>
       <p:sp>
         <p:nvSpPr>
-          <p:cNvPr id="13" name="Shape 9"/>
+          <p:cNvPr id="14" name="Shape 10"/>
           <p:cNvSpPr/>
           <p:nvPr/>
         </p:nvSpPr>
@@ -4048,7 +4124,7 @@
       </p:sp>
       <p:sp>
         <p:nvSpPr>
-          <p:cNvPr id="14" name="Pestaña Diagnóstico"/>
+          <p:cNvPr id="15" name="Pestaña Diagnóstico"/>
           <p:cNvSpPr txBox="1"/>
           <p:nvPr/>
         </p:nvSpPr>
@@ -4084,7 +4160,7 @@
       </p:sp>
       <p:sp>
         <p:nvSpPr>
-          <p:cNvPr id="15" name="Sección actual"/>
+          <p:cNvPr id="16" name="Sección actual"/>
           <p:cNvSpPr/>
           <p:nvPr/>
         </p:nvSpPr>
@@ -4109,7 +4185,7 @@
       </p:sp>
       <p:sp>
         <p:nvSpPr>
-          <p:cNvPr id="16" name="Pestaña Meta"/>
+          <p:cNvPr id="17" name="Pestaña Meta"/>
           <p:cNvSpPr txBox="1"/>
           <p:nvPr/>
         </p:nvSpPr>
@@ -4152,7 +4228,7 @@
       </p:sp>
       <p:sp>
         <p:nvSpPr>
-          <p:cNvPr id="17" name="Pestaña Plan y recomendación"/>
+          <p:cNvPr id="18" name="Pestaña Plan y recomendación"/>
           <p:cNvSpPr txBox="1"/>
           <p:nvPr/>
         </p:nvSpPr>
@@ -4195,7 +4271,7 @@
       </p:sp>
       <p:sp>
         <p:nvSpPr>
-          <p:cNvPr id="18" name="Pestaña Ficha técnica"/>
+          <p:cNvPr id="19" name="Pestaña Ficha técnica"/>
           <p:cNvSpPr txBox="1"/>
           <p:nvPr/>
         </p:nvSpPr>
@@ -4308,7 +4384,45 @@
       </p:grpSpPr>
       <p:sp>
         <p:nvSpPr>
-          <p:cNvPr id="2" name="Text 1"/>
+          <p:cNvPr id="2" name="Marca de agua"/>
+          <p:cNvSpPr txBox="1"/>
+          <p:nvPr/>
+        </p:nvSpPr>
+        <p:spPr>
+          <a:xfrm rot="-1200000">
+            <a:off x="-320040" y="2743200"/>
+            <a:ext cx="12801600" cy="1097280"/>
+          </a:xfrm>
+          <a:prstGeom prst="rect">
+            <a:avLst/>
+          </a:prstGeom>
+          <a:noFill/>
+          <a:ln/>
+        </p:spPr>
+        <p:txBody>
+          <a:bodyPr wrap="none" lIns="0" tIns="0" rIns="0" bIns="0" rtlCol="0" anchor="ctr"/>
+          <a:lstStyle/>
+          <a:p>
+            <a:pPr algn="ctr" indent="0" marL="0">
+              <a:buNone/>
+            </a:pPr>
+            <a:r>
+              <a:rPr lang="en-US" sz="4400" b="1" spc="200" kern="0" dirty="0">
+                <a:solidFill>
+                  <a:srgbClr val="002B63">
+                    <a:alpha val="8000"/>
+                  </a:srgbClr>
+                </a:solidFill>
+              </a:rPr>
+              <a:t>CONFIDENCIAL · USO INTERNO DEL CAD</a:t>
+            </a:r>
+            <a:endParaRPr lang="en-US" sz="4400" dirty="0"/>
+          </a:p>
+        </p:txBody>
+      </p:sp>
+      <p:sp>
+        <p:nvSpPr>
+          <p:cNvPr id="3" name="Text 1"/>
           <p:cNvSpPr/>
           <p:nvPr>
             <p:ph idx="101" type="title" hasCustomPrompt="1"/>
@@ -4346,7 +4460,7 @@
       </p:sp>
       <p:pic>
         <p:nvPicPr>
-          <p:cNvPr id="3" name="Mapa base" descr="/tmp/claude-0/-home-user-pdf-toolkit/a67bee5e-d5f3-51b1-8612-3e4feb352169/scratchpad/img/mapa_pa.png">    </p:cNvPr>
+          <p:cNvPr id="4" name="Mapa base" descr="/tmp/claude-0/-home-user-pdf-toolkit/a67bee5e-d5f3-51b1-8612-3e4feb352169/scratchpad/img/mapa_pa.png">    </p:cNvPr>
           <p:cNvPicPr>
             <a:picLocks noChangeAspect="1"/>
           </p:cNvPicPr>
@@ -4370,7 +4484,7 @@
       </p:pic>
       <p:sp>
         <p:nvSpPr>
-          <p:cNvPr id="4" name="Zona 1 Phila. Noreste"/>
+          <p:cNvPr id="5" name="Zona 1 Phila. Noreste"/>
           <p:cNvSpPr/>
           <p:nvPr/>
         </p:nvSpPr>
@@ -4395,7 +4509,7 @@
       </p:sp>
       <p:sp>
         <p:nvSpPr>
-          <p:cNvPr id="5" name="Text 2"/>
+          <p:cNvPr id="6" name="Text 3"/>
           <p:cNvSpPr txBox="1"/>
           <p:nvPr/>
         </p:nvSpPr>
@@ -4431,7 +4545,7 @@
       </p:sp>
       <p:sp>
         <p:nvSpPr>
-          <p:cNvPr id="6" name="Etiqueta Phila. Noreste"/>
+          <p:cNvPr id="7" name="Etiqueta Phila. Noreste"/>
           <p:cNvSpPr/>
           <p:nvPr/>
         </p:nvSpPr>
@@ -4458,7 +4572,7 @@
       </p:sp>
       <p:sp>
         <p:nvSpPr>
-          <p:cNvPr id="7" name="Text 4"/>
+          <p:cNvPr id="8" name="Text 5"/>
           <p:cNvSpPr txBox="1"/>
           <p:nvPr/>
         </p:nvSpPr>
@@ -4494,7 +4608,7 @@
       </p:sp>
       <p:sp>
         <p:nvSpPr>
-          <p:cNvPr id="8" name="Zona 2 Phila. Kensington"/>
+          <p:cNvPr id="9" name="Zona 2 Phila. Kensington"/>
           <p:cNvSpPr/>
           <p:nvPr/>
         </p:nvSpPr>
@@ -4519,7 +4633,7 @@
       </p:sp>
       <p:sp>
         <p:nvSpPr>
-          <p:cNvPr id="9" name="Text 6"/>
+          <p:cNvPr id="10" name="Text 7"/>
           <p:cNvSpPr txBox="1"/>
           <p:nvPr/>
         </p:nvSpPr>
@@ -4555,7 +4669,7 @@
       </p:sp>
       <p:sp>
         <p:nvSpPr>
-          <p:cNvPr id="10" name="Etiqueta Phila. Kensington"/>
+          <p:cNvPr id="11" name="Etiqueta Phila. Kensington"/>
           <p:cNvSpPr/>
           <p:nvPr/>
         </p:nvSpPr>
@@ -4582,7 +4696,7 @@
       </p:sp>
       <p:sp>
         <p:nvSpPr>
-          <p:cNvPr id="11" name="Text 8"/>
+          <p:cNvPr id="12" name="Text 9"/>
           <p:cNvSpPr txBox="1"/>
           <p:nvPr/>
         </p:nvSpPr>
@@ -4618,7 +4732,7 @@
       </p:sp>
       <p:sp>
         <p:nvSpPr>
-          <p:cNvPr id="12" name="Zona 3 Reading"/>
+          <p:cNvPr id="13" name="Zona 3 Reading"/>
           <p:cNvSpPr/>
           <p:nvPr/>
         </p:nvSpPr>
@@ -4643,7 +4757,7 @@
       </p:sp>
       <p:sp>
         <p:nvSpPr>
-          <p:cNvPr id="13" name="Text 10"/>
+          <p:cNvPr id="14" name="Text 11"/>
           <p:cNvSpPr txBox="1"/>
           <p:nvPr/>
         </p:nvSpPr>
@@ -4679,7 +4793,7 @@
       </p:sp>
       <p:sp>
         <p:nvSpPr>
-          <p:cNvPr id="14" name="Etiqueta Reading"/>
+          <p:cNvPr id="15" name="Etiqueta Reading"/>
           <p:cNvSpPr/>
           <p:nvPr/>
         </p:nvSpPr>
@@ -4706,7 +4820,7 @@
       </p:sp>
       <p:sp>
         <p:nvSpPr>
-          <p:cNvPr id="15" name="Text 12"/>
+          <p:cNvPr id="16" name="Text 13"/>
           <p:cNvSpPr txBox="1"/>
           <p:nvPr/>
         </p:nvSpPr>
@@ -4742,7 +4856,7 @@
       </p:sp>
       <p:sp>
         <p:nvSpPr>
-          <p:cNvPr id="16" name="Zona 4 Allentown"/>
+          <p:cNvPr id="17" name="Zona 4 Allentown"/>
           <p:cNvSpPr/>
           <p:nvPr/>
         </p:nvSpPr>
@@ -4767,7 +4881,7 @@
       </p:sp>
       <p:sp>
         <p:nvSpPr>
-          <p:cNvPr id="17" name="Text 14"/>
+          <p:cNvPr id="18" name="Text 15"/>
           <p:cNvSpPr txBox="1"/>
           <p:nvPr/>
         </p:nvSpPr>
@@ -4803,7 +4917,7 @@
       </p:sp>
       <p:sp>
         <p:nvSpPr>
-          <p:cNvPr id="18" name="Etiqueta Allentown"/>
+          <p:cNvPr id="19" name="Etiqueta Allentown"/>
           <p:cNvSpPr/>
           <p:nvPr/>
         </p:nvSpPr>
@@ -4830,7 +4944,7 @@
       </p:sp>
       <p:sp>
         <p:nvSpPr>
-          <p:cNvPr id="19" name="Text 16"/>
+          <p:cNvPr id="20" name="Text 17"/>
           <p:cNvSpPr txBox="1"/>
           <p:nvPr/>
         </p:nvSpPr>
@@ -4866,7 +4980,7 @@
       </p:sp>
       <p:sp>
         <p:nvSpPr>
-          <p:cNvPr id="20" name="Zona 5 Hazleton"/>
+          <p:cNvPr id="21" name="Zona 5 Hazleton"/>
           <p:cNvSpPr/>
           <p:nvPr/>
         </p:nvSpPr>
@@ -4891,7 +5005,7 @@
       </p:sp>
       <p:sp>
         <p:nvSpPr>
-          <p:cNvPr id="21" name="Text 18"/>
+          <p:cNvPr id="22" name="Text 19"/>
           <p:cNvSpPr txBox="1"/>
           <p:nvPr/>
         </p:nvSpPr>
@@ -4927,7 +5041,7 @@
       </p:sp>
       <p:sp>
         <p:nvSpPr>
-          <p:cNvPr id="22" name="Etiqueta Hazleton"/>
+          <p:cNvPr id="23" name="Etiqueta Hazleton"/>
           <p:cNvSpPr/>
           <p:nvPr/>
         </p:nvSpPr>
@@ -4954,7 +5068,7 @@
       </p:sp>
       <p:sp>
         <p:nvSpPr>
-          <p:cNvPr id="23" name="Text 20"/>
+          <p:cNvPr id="24" name="Text 21"/>
           <p:cNvSpPr txBox="1"/>
           <p:nvPr/>
         </p:nvSpPr>
@@ -4990,7 +5104,7 @@
       </p:sp>
       <p:sp>
         <p:nvSpPr>
-          <p:cNvPr id="24" name="Zona 6 Wilkes-Barre"/>
+          <p:cNvPr id="25" name="Zona 6 Wilkes-Barre"/>
           <p:cNvSpPr/>
           <p:nvPr/>
         </p:nvSpPr>
@@ -5015,7 +5129,7 @@
       </p:sp>
       <p:sp>
         <p:nvSpPr>
-          <p:cNvPr id="25" name="Text 22"/>
+          <p:cNvPr id="26" name="Text 23"/>
           <p:cNvSpPr txBox="1"/>
           <p:nvPr/>
         </p:nvSpPr>
@@ -5051,7 +5165,7 @@
       </p:sp>
       <p:sp>
         <p:nvSpPr>
-          <p:cNvPr id="26" name="Etiqueta Wilkes-Barre"/>
+          <p:cNvPr id="27" name="Etiqueta Wilkes-Barre"/>
           <p:cNvSpPr/>
           <p:nvPr/>
         </p:nvSpPr>
@@ -5078,7 +5192,7 @@
       </p:sp>
       <p:sp>
         <p:nvSpPr>
-          <p:cNvPr id="27" name="Text 24"/>
+          <p:cNvPr id="28" name="Text 25"/>
           <p:cNvSpPr txBox="1"/>
           <p:nvPr/>
         </p:nvSpPr>
@@ -5114,7 +5228,7 @@
       </p:sp>
       <p:sp>
         <p:nvSpPr>
-          <p:cNvPr id="28" name="Zona 6 Scranton"/>
+          <p:cNvPr id="29" name="Zona 6 Scranton"/>
           <p:cNvSpPr/>
           <p:nvPr/>
         </p:nvSpPr>
@@ -5139,7 +5253,7 @@
       </p:sp>
       <p:sp>
         <p:nvSpPr>
-          <p:cNvPr id="29" name="Text 26"/>
+          <p:cNvPr id="30" name="Text 27"/>
           <p:cNvSpPr txBox="1"/>
           <p:nvPr/>
         </p:nvSpPr>
@@ -5175,7 +5289,7 @@
       </p:sp>
       <p:sp>
         <p:nvSpPr>
-          <p:cNvPr id="30" name="Etiqueta Scranton"/>
+          <p:cNvPr id="31" name="Etiqueta Scranton"/>
           <p:cNvSpPr/>
           <p:nvPr/>
         </p:nvSpPr>
@@ -5202,7 +5316,7 @@
       </p:sp>
       <p:sp>
         <p:nvSpPr>
-          <p:cNvPr id="31" name="Text 28"/>
+          <p:cNvPr id="32" name="Text 29"/>
           <p:cNvSpPr txBox="1"/>
           <p:nvPr/>
         </p:nvSpPr>
@@ -5238,7 +5352,7 @@
       </p:sp>
       <p:sp>
         <p:nvSpPr>
-          <p:cNvPr id="32" name="Zona 7 Harrisburg"/>
+          <p:cNvPr id="33" name="Zona 7 Harrisburg"/>
           <p:cNvSpPr/>
           <p:nvPr/>
         </p:nvSpPr>
@@ -5263,7 +5377,7 @@
       </p:sp>
       <p:sp>
         <p:nvSpPr>
-          <p:cNvPr id="33" name="Text 30"/>
+          <p:cNvPr id="34" name="Text 31"/>
           <p:cNvSpPr txBox="1"/>
           <p:nvPr/>
         </p:nvSpPr>
@@ -5299,7 +5413,7 @@
       </p:sp>
       <p:sp>
         <p:nvSpPr>
-          <p:cNvPr id="34" name="Etiqueta Harrisburg"/>
+          <p:cNvPr id="35" name="Etiqueta Harrisburg"/>
           <p:cNvSpPr/>
           <p:nvPr/>
         </p:nvSpPr>
@@ -5326,7 +5440,7 @@
       </p:sp>
       <p:sp>
         <p:nvSpPr>
-          <p:cNvPr id="35" name="Text 32"/>
+          <p:cNvPr id="36" name="Text 33"/>
           <p:cNvSpPr txBox="1"/>
           <p:nvPr/>
         </p:nvSpPr>
@@ -5362,7 +5476,7 @@
       </p:sp>
       <p:sp>
         <p:nvSpPr>
-          <p:cNvPr id="36" name="Zona 7 Lebanon"/>
+          <p:cNvPr id="37" name="Zona 7 Lebanon"/>
           <p:cNvSpPr/>
           <p:nvPr/>
         </p:nvSpPr>
@@ -5387,7 +5501,7 @@
       </p:sp>
       <p:sp>
         <p:nvSpPr>
-          <p:cNvPr id="37" name="Text 34"/>
+          <p:cNvPr id="38" name="Text 35"/>
           <p:cNvSpPr txBox="1"/>
           <p:nvPr/>
         </p:nvSpPr>
@@ -5423,7 +5537,7 @@
       </p:sp>
       <p:sp>
         <p:nvSpPr>
-          <p:cNvPr id="38" name="Etiqueta Lebanon"/>
+          <p:cNvPr id="39" name="Etiqueta Lebanon"/>
           <p:cNvSpPr/>
           <p:nvPr/>
         </p:nvSpPr>
@@ -5450,7 +5564,7 @@
       </p:sp>
       <p:sp>
         <p:nvSpPr>
-          <p:cNvPr id="39" name="Text 36"/>
+          <p:cNvPr id="40" name="Text 37"/>
           <p:cNvSpPr txBox="1"/>
           <p:nvPr/>
         </p:nvSpPr>
@@ -5486,7 +5600,7 @@
       </p:sp>
       <p:sp>
         <p:nvSpPr>
-          <p:cNvPr id="40" name="Zona 7 Lancaster"/>
+          <p:cNvPr id="41" name="Zona 7 Lancaster"/>
           <p:cNvSpPr/>
           <p:nvPr/>
         </p:nvSpPr>
@@ -5511,7 +5625,7 @@
       </p:sp>
       <p:sp>
         <p:nvSpPr>
-          <p:cNvPr id="41" name="Text 38"/>
+          <p:cNvPr id="42" name="Text 39"/>
           <p:cNvSpPr txBox="1"/>
           <p:nvPr/>
         </p:nvSpPr>
@@ -5547,7 +5661,7 @@
       </p:sp>
       <p:sp>
         <p:nvSpPr>
-          <p:cNvPr id="42" name="Etiqueta Lancaster"/>
+          <p:cNvPr id="43" name="Etiqueta Lancaster"/>
           <p:cNvSpPr/>
           <p:nvPr/>
         </p:nvSpPr>
@@ -5574,7 +5688,7 @@
       </p:sp>
       <p:sp>
         <p:nvSpPr>
-          <p:cNvPr id="43" name="Text 40"/>
+          <p:cNvPr id="44" name="Text 41"/>
           <p:cNvSpPr txBox="1"/>
           <p:nvPr/>
         </p:nvSpPr>
@@ -5610,7 +5724,7 @@
       </p:sp>
       <p:sp>
         <p:nvSpPr>
-          <p:cNvPr id="44" name="Zona 7 York"/>
+          <p:cNvPr id="45" name="Zona 7 York"/>
           <p:cNvSpPr/>
           <p:nvPr/>
         </p:nvSpPr>
@@ -5635,7 +5749,7 @@
       </p:sp>
       <p:sp>
         <p:nvSpPr>
-          <p:cNvPr id="45" name="Text 42"/>
+          <p:cNvPr id="46" name="Text 43"/>
           <p:cNvSpPr txBox="1"/>
           <p:nvPr/>
         </p:nvSpPr>
@@ -5671,7 +5785,7 @@
       </p:sp>
       <p:sp>
         <p:nvSpPr>
-          <p:cNvPr id="46" name="Etiqueta York"/>
+          <p:cNvPr id="47" name="Etiqueta York"/>
           <p:cNvSpPr/>
           <p:nvPr/>
         </p:nvSpPr>
@@ -5698,7 +5812,7 @@
       </p:sp>
       <p:sp>
         <p:nvSpPr>
-          <p:cNvPr id="47" name="Text 44"/>
+          <p:cNvPr id="48" name="Text 45"/>
           <p:cNvSpPr txBox="1"/>
           <p:nvPr/>
         </p:nvSpPr>
@@ -5734,7 +5848,7 @@
       </p:sp>
       <p:sp>
         <p:nvSpPr>
-          <p:cNvPr id="48" name="Zona 8 Wilmington"/>
+          <p:cNvPr id="49" name="Zona 8 Wilmington"/>
           <p:cNvSpPr/>
           <p:nvPr/>
         </p:nvSpPr>
@@ -5759,7 +5873,7 @@
       </p:sp>
       <p:sp>
         <p:nvSpPr>
-          <p:cNvPr id="49" name="Text 46"/>
+          <p:cNvPr id="50" name="Text 47"/>
           <p:cNvSpPr txBox="1"/>
           <p:nvPr/>
         </p:nvSpPr>
@@ -5795,7 +5909,7 @@
       </p:sp>
       <p:sp>
         <p:nvSpPr>
-          <p:cNvPr id="50" name="Etiqueta Wilmington"/>
+          <p:cNvPr id="51" name="Etiqueta Wilmington"/>
           <p:cNvSpPr/>
           <p:nvPr/>
         </p:nvSpPr>
@@ -5822,7 +5936,7 @@
       </p:sp>
       <p:sp>
         <p:nvSpPr>
-          <p:cNvPr id="51" name="Text 48"/>
+          <p:cNvPr id="52" name="Text 49"/>
           <p:cNvSpPr txBox="1"/>
           <p:nvPr/>
         </p:nvSpPr>
@@ -5858,7 +5972,7 @@
       </p:sp>
       <p:sp>
         <p:nvSpPr>
-          <p:cNvPr id="52" name="Text 49"/>
+          <p:cNvPr id="53" name="Text 50"/>
           <p:cNvSpPr txBox="1"/>
           <p:nvPr/>
         </p:nvSpPr>
@@ -5894,7 +6008,7 @@
       </p:sp>
       <p:sp>
         <p:nvSpPr>
-          <p:cNvPr id="53" name="Text 50"/>
+          <p:cNvPr id="54" name="Text 51"/>
           <p:cNvSpPr txBox="1"/>
           <p:nvPr/>
         </p:nvSpPr>
@@ -5930,7 +6044,7 @@
       </p:sp>
       <p:sp>
         <p:nvSpPr>
-          <p:cNvPr id="54" name="Shape 51"/>
+          <p:cNvPr id="55" name="Shape 52"/>
           <p:cNvSpPr/>
           <p:nvPr/>
         </p:nvSpPr>
@@ -5955,7 +6069,7 @@
       </p:sp>
       <p:sp>
         <p:nvSpPr>
-          <p:cNvPr id="55" name="Text 52"/>
+          <p:cNvPr id="56" name="Text 53"/>
           <p:cNvSpPr txBox="1"/>
           <p:nvPr/>
         </p:nvSpPr>
@@ -5991,7 +6105,7 @@
       </p:sp>
       <p:sp>
         <p:nvSpPr>
-          <p:cNvPr id="56" name="Text 53"/>
+          <p:cNvPr id="57" name="Text 54"/>
           <p:cNvSpPr txBox="1"/>
           <p:nvPr/>
         </p:nvSpPr>
@@ -6041,7 +6155,7 @@
       </p:sp>
       <p:sp>
         <p:nvSpPr>
-          <p:cNvPr id="57" name="Text 54"/>
+          <p:cNvPr id="58" name="Text 55"/>
           <p:cNvSpPr txBox="1"/>
           <p:nvPr/>
         </p:nvSpPr>
@@ -6077,7 +6191,7 @@
       </p:sp>
       <p:sp>
         <p:nvSpPr>
-          <p:cNvPr id="58" name="Shape 55"/>
+          <p:cNvPr id="59" name="Shape 56"/>
           <p:cNvSpPr/>
           <p:nvPr/>
         </p:nvSpPr>
@@ -6102,7 +6216,7 @@
       </p:sp>
       <p:sp>
         <p:nvSpPr>
-          <p:cNvPr id="59" name="Text 56"/>
+          <p:cNvPr id="60" name="Text 57"/>
           <p:cNvSpPr txBox="1"/>
           <p:nvPr/>
         </p:nvSpPr>
@@ -6138,7 +6252,7 @@
       </p:sp>
       <p:sp>
         <p:nvSpPr>
-          <p:cNvPr id="60" name="Text 57"/>
+          <p:cNvPr id="61" name="Text 58"/>
           <p:cNvSpPr txBox="1"/>
           <p:nvPr/>
         </p:nvSpPr>
@@ -6188,7 +6302,7 @@
       </p:sp>
       <p:sp>
         <p:nvSpPr>
-          <p:cNvPr id="61" name="Text 58"/>
+          <p:cNvPr id="62" name="Text 59"/>
           <p:cNvSpPr txBox="1"/>
           <p:nvPr/>
         </p:nvSpPr>
@@ -6224,7 +6338,7 @@
       </p:sp>
       <p:sp>
         <p:nvSpPr>
-          <p:cNvPr id="62" name="Shape 59"/>
+          <p:cNvPr id="63" name="Shape 60"/>
           <p:cNvSpPr/>
           <p:nvPr/>
         </p:nvSpPr>
@@ -6249,7 +6363,7 @@
       </p:sp>
       <p:sp>
         <p:nvSpPr>
-          <p:cNvPr id="63" name="Text 60"/>
+          <p:cNvPr id="64" name="Text 61"/>
           <p:cNvSpPr txBox="1"/>
           <p:nvPr/>
         </p:nvSpPr>
@@ -6285,7 +6399,7 @@
       </p:sp>
       <p:sp>
         <p:nvSpPr>
-          <p:cNvPr id="64" name="Text 61"/>
+          <p:cNvPr id="65" name="Text 62"/>
           <p:cNvSpPr txBox="1"/>
           <p:nvPr/>
         </p:nvSpPr>
@@ -6335,7 +6449,7 @@
       </p:sp>
       <p:sp>
         <p:nvSpPr>
-          <p:cNvPr id="65" name="Text 62"/>
+          <p:cNvPr id="66" name="Text 63"/>
           <p:cNvSpPr txBox="1"/>
           <p:nvPr/>
         </p:nvSpPr>
@@ -6371,7 +6485,7 @@
       </p:sp>
       <p:sp>
         <p:nvSpPr>
-          <p:cNvPr id="66" name="Shape 63"/>
+          <p:cNvPr id="67" name="Shape 64"/>
           <p:cNvSpPr/>
           <p:nvPr/>
         </p:nvSpPr>
@@ -6396,7 +6510,7 @@
       </p:sp>
       <p:sp>
         <p:nvSpPr>
-          <p:cNvPr id="67" name="Text 64"/>
+          <p:cNvPr id="68" name="Text 65"/>
           <p:cNvSpPr txBox="1"/>
           <p:nvPr/>
         </p:nvSpPr>
@@ -6432,7 +6546,7 @@
       </p:sp>
       <p:sp>
         <p:nvSpPr>
-          <p:cNvPr id="68" name="Text 65"/>
+          <p:cNvPr id="69" name="Text 66"/>
           <p:cNvSpPr txBox="1"/>
           <p:nvPr/>
         </p:nvSpPr>
@@ -6482,7 +6596,7 @@
       </p:sp>
       <p:sp>
         <p:nvSpPr>
-          <p:cNvPr id="69" name="Text 66"/>
+          <p:cNvPr id="70" name="Text 67"/>
           <p:cNvSpPr txBox="1"/>
           <p:nvPr/>
         </p:nvSpPr>
@@ -6518,7 +6632,7 @@
       </p:sp>
       <p:sp>
         <p:nvSpPr>
-          <p:cNvPr id="70" name="Shape 67"/>
+          <p:cNvPr id="71" name="Shape 68"/>
           <p:cNvSpPr/>
           <p:nvPr/>
         </p:nvSpPr>
@@ -6543,7 +6657,7 @@
       </p:sp>
       <p:sp>
         <p:nvSpPr>
-          <p:cNvPr id="71" name="Text 68"/>
+          <p:cNvPr id="72" name="Text 69"/>
           <p:cNvSpPr txBox="1"/>
           <p:nvPr/>
         </p:nvSpPr>
@@ -6579,7 +6693,7 @@
       </p:sp>
       <p:sp>
         <p:nvSpPr>
-          <p:cNvPr id="72" name="Text 69"/>
+          <p:cNvPr id="73" name="Text 70"/>
           <p:cNvSpPr txBox="1"/>
           <p:nvPr/>
         </p:nvSpPr>
@@ -6629,7 +6743,7 @@
       </p:sp>
       <p:sp>
         <p:nvSpPr>
-          <p:cNvPr id="73" name="Text 70"/>
+          <p:cNvPr id="74" name="Text 71"/>
           <p:cNvSpPr txBox="1"/>
           <p:nvPr/>
         </p:nvSpPr>
@@ -6665,7 +6779,7 @@
       </p:sp>
       <p:sp>
         <p:nvSpPr>
-          <p:cNvPr id="74" name="Shape 71"/>
+          <p:cNvPr id="75" name="Shape 72"/>
           <p:cNvSpPr/>
           <p:nvPr/>
         </p:nvSpPr>
@@ -6690,7 +6804,7 @@
       </p:sp>
       <p:sp>
         <p:nvSpPr>
-          <p:cNvPr id="75" name="Text 72"/>
+          <p:cNvPr id="76" name="Text 73"/>
           <p:cNvSpPr txBox="1"/>
           <p:nvPr/>
         </p:nvSpPr>
@@ -6726,7 +6840,7 @@
       </p:sp>
       <p:sp>
         <p:nvSpPr>
-          <p:cNvPr id="76" name="Text 73"/>
+          <p:cNvPr id="77" name="Text 74"/>
           <p:cNvSpPr txBox="1"/>
           <p:nvPr/>
         </p:nvSpPr>
@@ -6776,7 +6890,7 @@
       </p:sp>
       <p:sp>
         <p:nvSpPr>
-          <p:cNvPr id="77" name="Text 74"/>
+          <p:cNvPr id="78" name="Text 75"/>
           <p:cNvSpPr txBox="1"/>
           <p:nvPr/>
         </p:nvSpPr>
@@ -6812,7 +6926,7 @@
       </p:sp>
       <p:sp>
         <p:nvSpPr>
-          <p:cNvPr id="78" name="Shape 75"/>
+          <p:cNvPr id="79" name="Shape 76"/>
           <p:cNvSpPr/>
           <p:nvPr/>
         </p:nvSpPr>
@@ -6837,7 +6951,7 @@
       </p:sp>
       <p:sp>
         <p:nvSpPr>
-          <p:cNvPr id="79" name="Text 76"/>
+          <p:cNvPr id="80" name="Text 77"/>
           <p:cNvSpPr txBox="1"/>
           <p:nvPr/>
         </p:nvSpPr>
@@ -6873,7 +6987,7 @@
       </p:sp>
       <p:sp>
         <p:nvSpPr>
-          <p:cNvPr id="80" name="Text 77"/>
+          <p:cNvPr id="81" name="Text 78"/>
           <p:cNvSpPr txBox="1"/>
           <p:nvPr/>
         </p:nvSpPr>
@@ -6923,7 +7037,7 @@
       </p:sp>
       <p:sp>
         <p:nvSpPr>
-          <p:cNvPr id="81" name="Text 78"/>
+          <p:cNvPr id="82" name="Text 79"/>
           <p:cNvSpPr txBox="1"/>
           <p:nvPr/>
         </p:nvSpPr>
@@ -6959,7 +7073,7 @@
       </p:sp>
       <p:sp>
         <p:nvSpPr>
-          <p:cNvPr id="82" name="Shape 79"/>
+          <p:cNvPr id="83" name="Shape 80"/>
           <p:cNvSpPr/>
           <p:nvPr/>
         </p:nvSpPr>
@@ -6984,7 +7098,7 @@
       </p:sp>
       <p:sp>
         <p:nvSpPr>
-          <p:cNvPr id="83" name="Text 80"/>
+          <p:cNvPr id="84" name="Text 81"/>
           <p:cNvSpPr txBox="1"/>
           <p:nvPr/>
         </p:nvSpPr>
@@ -7020,7 +7134,7 @@
       </p:sp>
       <p:sp>
         <p:nvSpPr>
-          <p:cNvPr id="84" name="Text 81"/>
+          <p:cNvPr id="85" name="Text 82"/>
           <p:cNvSpPr txBox="1"/>
           <p:nvPr/>
         </p:nvSpPr>
@@ -7070,7 +7184,7 @@
       </p:sp>
       <p:sp>
         <p:nvSpPr>
-          <p:cNvPr id="85" name="Text 82"/>
+          <p:cNvPr id="86" name="Text 83"/>
           <p:cNvSpPr txBox="1"/>
           <p:nvPr/>
         </p:nvSpPr>
@@ -7106,7 +7220,7 @@
       </p:sp>
       <p:sp>
         <p:nvSpPr>
-          <p:cNvPr id="86" name="Fuente"/>
+          <p:cNvPr id="87" name="Fuente"/>
           <p:cNvSpPr txBox="1"/>
           <p:nvPr/>
         </p:nvSpPr>
@@ -7142,7 +7256,7 @@
       </p:sp>
       <p:sp>
         <p:nvSpPr>
-          <p:cNvPr id="88" name="Barra de navegación"/>
+          <p:cNvPr id="89" name="Barra de navegación"/>
           <p:cNvSpPr/>
           <p:nvPr/>
         </p:nvSpPr>
@@ -7167,7 +7281,7 @@
       </p:sp>
       <p:sp>
         <p:nvSpPr>
-          <p:cNvPr id="89" name="Shape 85"/>
+          <p:cNvPr id="90" name="Shape 86"/>
           <p:cNvSpPr/>
           <p:nvPr/>
         </p:nvSpPr>
@@ -7190,7 +7304,7 @@
       </p:sp>
       <p:sp>
         <p:nvSpPr>
-          <p:cNvPr id="90" name="Pestaña Diagnóstico"/>
+          <p:cNvPr id="91" name="Pestaña Diagnóstico"/>
           <p:cNvSpPr txBox="1"/>
           <p:nvPr/>
         </p:nvSpPr>
@@ -7226,7 +7340,7 @@
       </p:sp>
       <p:sp>
         <p:nvSpPr>
-          <p:cNvPr id="91" name="Sección actual"/>
+          <p:cNvPr id="92" name="Sección actual"/>
           <p:cNvSpPr/>
           <p:nvPr/>
         </p:nvSpPr>
@@ -7251,7 +7365,7 @@
       </p:sp>
       <p:sp>
         <p:nvSpPr>
-          <p:cNvPr id="92" name="Pestaña Meta"/>
+          <p:cNvPr id="93" name="Pestaña Meta"/>
           <p:cNvSpPr txBox="1"/>
           <p:nvPr/>
         </p:nvSpPr>
@@ -7294,7 +7408,7 @@
       </p:sp>
       <p:sp>
         <p:nvSpPr>
-          <p:cNvPr id="93" name="Pestaña Plan y recomendación"/>
+          <p:cNvPr id="94" name="Pestaña Plan y recomendación"/>
           <p:cNvSpPr txBox="1"/>
           <p:nvPr/>
         </p:nvSpPr>
@@ -7337,7 +7451,7 @@
       </p:sp>
       <p:sp>
         <p:nvSpPr>
-          <p:cNvPr id="94" name="Pestaña Ficha técnica"/>
+          <p:cNvPr id="95" name="Pestaña Ficha técnica"/>
           <p:cNvSpPr txBox="1"/>
           <p:nvPr/>
         </p:nvSpPr>
@@ -7450,7 +7564,45 @@
       </p:grpSpPr>
       <p:sp>
         <p:nvSpPr>
-          <p:cNvPr id="2" name="Text 1"/>
+          <p:cNvPr id="2" name="Marca de agua"/>
+          <p:cNvSpPr txBox="1"/>
+          <p:nvPr/>
+        </p:nvSpPr>
+        <p:spPr>
+          <a:xfrm rot="-1200000">
+            <a:off x="-320040" y="2743200"/>
+            <a:ext cx="12801600" cy="1097280"/>
+          </a:xfrm>
+          <a:prstGeom prst="rect">
+            <a:avLst/>
+          </a:prstGeom>
+          <a:noFill/>
+          <a:ln/>
+        </p:spPr>
+        <p:txBody>
+          <a:bodyPr wrap="none" lIns="0" tIns="0" rIns="0" bIns="0" rtlCol="0" anchor="ctr"/>
+          <a:lstStyle/>
+          <a:p>
+            <a:pPr algn="ctr" indent="0" marL="0">
+              <a:buNone/>
+            </a:pPr>
+            <a:r>
+              <a:rPr lang="en-US" sz="4400" b="1" spc="200" kern="0" dirty="0">
+                <a:solidFill>
+                  <a:srgbClr val="002B63">
+                    <a:alpha val="8000"/>
+                  </a:srgbClr>
+                </a:solidFill>
+              </a:rPr>
+              <a:t>CONFIDENCIAL · USO INTERNO DEL CAD</a:t>
+            </a:r>
+            <a:endParaRPr lang="en-US" sz="4400" dirty="0"/>
+          </a:p>
+        </p:txBody>
+      </p:sp>
+      <p:sp>
+        <p:nvSpPr>
+          <p:cNvPr id="3" name="Text 1"/>
           <p:cNvSpPr/>
           <p:nvPr>
             <p:ph idx="101" type="title" hasCustomPrompt="1"/>
@@ -7488,7 +7640,7 @@
       </p:sp>
       <p:graphicFrame>
         <p:nvGraphicFramePr>
-          <p:cNvPr id="3" name="Comparacion PRM" descr=""/>
+          <p:cNvPr id="4" name="Comparacion PRM" descr=""/>
           <p:cNvGraphicFramePr/>
           <p:nvPr/>
         </p:nvGraphicFramePr>
@@ -7504,7 +7656,7 @@
       </p:graphicFrame>
       <p:sp>
         <p:nvSpPr>
-          <p:cNvPr id="4" name="Text 1"/>
+          <p:cNvPr id="5" name="Text 2"/>
           <p:cNvSpPr txBox="1"/>
           <p:nvPr/>
         </p:nvSpPr>
@@ -7551,7 +7703,7 @@
       </p:sp>
       <p:sp>
         <p:nvSpPr>
-          <p:cNvPr id="5" name="Tres niveles"/>
+          <p:cNvPr id="6" name="Tres niveles"/>
           <p:cNvSpPr/>
           <p:nvPr/>
         </p:nvSpPr>
@@ -7578,7 +7730,7 @@
       </p:sp>
       <p:sp>
         <p:nvSpPr>
-          <p:cNvPr id="6" name="Text 3"/>
+          <p:cNvPr id="7" name="Text 4"/>
           <p:cNvSpPr txBox="1"/>
           <p:nvPr/>
         </p:nvSpPr>
@@ -7614,7 +7766,7 @@
       </p:sp>
       <p:sp>
         <p:nvSpPr>
-          <p:cNvPr id="7" name="Text 4"/>
+          <p:cNvPr id="8" name="Text 5"/>
           <p:cNvSpPr txBox="1"/>
           <p:nvPr/>
         </p:nvSpPr>
@@ -7661,7 +7813,7 @@
       </p:sp>
       <p:sp>
         <p:nvSpPr>
-          <p:cNvPr id="8" name="Text 5"/>
+          <p:cNvPr id="9" name="Text 6"/>
           <p:cNvSpPr txBox="1"/>
           <p:nvPr/>
         </p:nvSpPr>
@@ -7697,7 +7849,7 @@
       </p:sp>
       <p:sp>
         <p:nvSpPr>
-          <p:cNvPr id="9" name="Text 6"/>
+          <p:cNvPr id="10" name="Text 7"/>
           <p:cNvSpPr txBox="1"/>
           <p:nvPr/>
         </p:nvSpPr>
@@ -7744,7 +7896,7 @@
       </p:sp>
       <p:sp>
         <p:nvSpPr>
-          <p:cNvPr id="10" name="Text 7"/>
+          <p:cNvPr id="11" name="Text 8"/>
           <p:cNvSpPr txBox="1"/>
           <p:nvPr/>
         </p:nvSpPr>
@@ -7780,7 +7932,7 @@
       </p:sp>
       <p:sp>
         <p:nvSpPr>
-          <p:cNvPr id="11" name="Text 8"/>
+          <p:cNvPr id="12" name="Text 9"/>
           <p:cNvSpPr txBox="1"/>
           <p:nvPr/>
         </p:nvSpPr>
@@ -7827,7 +7979,7 @@
       </p:sp>
       <p:sp>
         <p:nvSpPr>
-          <p:cNvPr id="12" name="Text 9"/>
+          <p:cNvPr id="13" name="Text 10"/>
           <p:cNvSpPr txBox="1"/>
           <p:nvPr/>
         </p:nvSpPr>
@@ -7863,7 +8015,7 @@
       </p:sp>
       <p:sp>
         <p:nvSpPr>
-          <p:cNvPr id="13" name="Desgaste"/>
+          <p:cNvPr id="14" name="Desgaste"/>
           <p:cNvSpPr/>
           <p:nvPr/>
         </p:nvSpPr>
@@ -7890,7 +8042,7 @@
       </p:sp>
       <p:sp>
         <p:nvSpPr>
-          <p:cNvPr id="14" name="Text 11"/>
+          <p:cNvPr id="15" name="Text 12"/>
           <p:cNvSpPr txBox="1"/>
           <p:nvPr/>
         </p:nvSpPr>
@@ -7926,7 +8078,7 @@
       </p:sp>
       <p:sp>
         <p:nvSpPr>
-          <p:cNvPr id="15" name="Text 12"/>
+          <p:cNvPr id="16" name="Text 13"/>
           <p:cNvSpPr txBox="1"/>
           <p:nvPr/>
         </p:nvSpPr>
@@ -7962,7 +8114,7 @@
       </p:sp>
       <p:sp>
         <p:nvSpPr>
-          <p:cNvPr id="16" name="Text 13"/>
+          <p:cNvPr id="17" name="Text 14"/>
           <p:cNvSpPr txBox="1"/>
           <p:nvPr/>
         </p:nvSpPr>
@@ -7998,7 +8150,7 @@
       </p:sp>
       <p:sp>
         <p:nvSpPr>
-          <p:cNvPr id="17" name="Text 14"/>
+          <p:cNvPr id="18" name="Text 15"/>
           <p:cNvSpPr txBox="1"/>
           <p:nvPr/>
         </p:nvSpPr>
@@ -8034,7 +8186,7 @@
       </p:sp>
       <p:sp>
         <p:nvSpPr>
-          <p:cNvPr id="18" name="Text 15"/>
+          <p:cNvPr id="19" name="Text 16"/>
           <p:cNvSpPr txBox="1"/>
           <p:nvPr/>
         </p:nvSpPr>
@@ -8070,7 +8222,7 @@
       </p:sp>
       <p:sp>
         <p:nvSpPr>
-          <p:cNvPr id="19" name="Text 16"/>
+          <p:cNvPr id="20" name="Text 17"/>
           <p:cNvSpPr txBox="1"/>
           <p:nvPr/>
         </p:nvSpPr>
@@ -8106,7 +8258,7 @@
       </p:sp>
       <p:sp>
         <p:nvSpPr>
-          <p:cNvPr id="20" name="Text 17"/>
+          <p:cNvPr id="21" name="Text 18"/>
           <p:cNvSpPr txBox="1"/>
           <p:nvPr/>
         </p:nvSpPr>
@@ -8142,7 +8294,7 @@
       </p:sp>
       <p:sp>
         <p:nvSpPr>
-          <p:cNvPr id="21" name="Fuente"/>
+          <p:cNvPr id="22" name="Fuente"/>
           <p:cNvSpPr txBox="1"/>
           <p:nvPr/>
         </p:nvSpPr>
@@ -8178,7 +8330,7 @@
       </p:sp>
       <p:sp>
         <p:nvSpPr>
-          <p:cNvPr id="23" name="Barra de navegación"/>
+          <p:cNvPr id="24" name="Barra de navegación"/>
           <p:cNvSpPr/>
           <p:nvPr/>
         </p:nvSpPr>
@@ -8203,7 +8355,7 @@
       </p:sp>
       <p:sp>
         <p:nvSpPr>
-          <p:cNvPr id="24" name="Shape 20"/>
+          <p:cNvPr id="25" name="Shape 21"/>
           <p:cNvSpPr/>
           <p:nvPr/>
         </p:nvSpPr>
@@ -8226,7 +8378,7 @@
       </p:sp>
       <p:sp>
         <p:nvSpPr>
-          <p:cNvPr id="25" name="Pestaña Diagnóstico"/>
+          <p:cNvPr id="26" name="Pestaña Diagnóstico"/>
           <p:cNvSpPr txBox="1"/>
           <p:nvPr/>
         </p:nvSpPr>
@@ -8269,7 +8421,7 @@
       </p:sp>
       <p:sp>
         <p:nvSpPr>
-          <p:cNvPr id="26" name="Pestaña Meta"/>
+          <p:cNvPr id="27" name="Pestaña Meta"/>
           <p:cNvSpPr txBox="1"/>
           <p:nvPr/>
         </p:nvSpPr>
@@ -8305,7 +8457,7 @@
       </p:sp>
       <p:sp>
         <p:nvSpPr>
-          <p:cNvPr id="27" name="Sección actual"/>
+          <p:cNvPr id="28" name="Sección actual"/>
           <p:cNvSpPr/>
           <p:nvPr/>
         </p:nvSpPr>
@@ -8330,7 +8482,7 @@
       </p:sp>
       <p:sp>
         <p:nvSpPr>
-          <p:cNvPr id="28" name="Pestaña Plan y recomendación"/>
+          <p:cNvPr id="29" name="Pestaña Plan y recomendación"/>
           <p:cNvSpPr txBox="1"/>
           <p:nvPr/>
         </p:nvSpPr>
@@ -8373,7 +8525,7 @@
       </p:sp>
       <p:sp>
         <p:nvSpPr>
-          <p:cNvPr id="29" name="Pestaña Ficha técnica"/>
+          <p:cNvPr id="30" name="Pestaña Ficha técnica"/>
           <p:cNvSpPr txBox="1"/>
           <p:nvPr/>
         </p:nvSpPr>
@@ -8486,7 +8638,45 @@
       </p:grpSpPr>
       <p:sp>
         <p:nvSpPr>
-          <p:cNvPr id="2" name="Text 1"/>
+          <p:cNvPr id="2" name="Marca de agua"/>
+          <p:cNvSpPr txBox="1"/>
+          <p:nvPr/>
+        </p:nvSpPr>
+        <p:spPr>
+          <a:xfrm rot="-1200000">
+            <a:off x="-320040" y="2743200"/>
+            <a:ext cx="12801600" cy="1097280"/>
+          </a:xfrm>
+          <a:prstGeom prst="rect">
+            <a:avLst/>
+          </a:prstGeom>
+          <a:noFill/>
+          <a:ln/>
+        </p:spPr>
+        <p:txBody>
+          <a:bodyPr wrap="none" lIns="0" tIns="0" rIns="0" bIns="0" rtlCol="0" anchor="ctr"/>
+          <a:lstStyle/>
+          <a:p>
+            <a:pPr algn="ctr" indent="0" marL="0">
+              <a:buNone/>
+            </a:pPr>
+            <a:r>
+              <a:rPr lang="en-US" sz="4400" b="1" spc="200" kern="0" dirty="0">
+                <a:solidFill>
+                  <a:srgbClr val="002B63">
+                    <a:alpha val="8000"/>
+                  </a:srgbClr>
+                </a:solidFill>
+              </a:rPr>
+              <a:t>CONFIDENCIAL · USO INTERNO DEL CAD</a:t>
+            </a:r>
+            <a:endParaRPr lang="en-US" sz="4400" dirty="0"/>
+          </a:p>
+        </p:txBody>
+      </p:sp>
+      <p:sp>
+        <p:nvSpPr>
+          <p:cNvPr id="3" name="Text 1"/>
           <p:cNvSpPr/>
           <p:nvPr>
             <p:ph idx="101" type="title" hasCustomPrompt="1"/>
@@ -8524,7 +8714,7 @@
       </p:sp>
       <p:sp>
         <p:nvSpPr>
-          <p:cNvPr id="3" name="Direccion ejecutiva"/>
+          <p:cNvPr id="4" name="Direccion ejecutiva"/>
           <p:cNvSpPr/>
           <p:nvPr/>
         </p:nvSpPr>
@@ -8551,7 +8741,7 @@
       </p:sp>
       <p:sp>
         <p:nvSpPr>
-          <p:cNvPr id="4" name="Text 2"/>
+          <p:cNvPr id="5" name="Text 3"/>
           <p:cNvSpPr txBox="1"/>
           <p:nvPr/>
         </p:nvSpPr>
@@ -8587,7 +8777,7 @@
       </p:sp>
       <p:sp>
         <p:nvSpPr>
-          <p:cNvPr id="5" name="Seccional PRM"/>
+          <p:cNvPr id="6" name="Seccional PRM"/>
           <p:cNvSpPr/>
           <p:nvPr/>
         </p:nvSpPr>
@@ -8614,7 +8804,7 @@
       </p:sp>
       <p:sp>
         <p:nvSpPr>
-          <p:cNvPr id="6" name="Text 4"/>
+          <p:cNvPr id="7" name="Text 5"/>
           <p:cNvSpPr txBox="1"/>
           <p:nvPr/>
         </p:nvSpPr>
@@ -8650,7 +8840,7 @@
       </p:sp>
       <p:sp>
         <p:nvSpPr>
-          <p:cNvPr id="7" name="Shape 5"/>
+          <p:cNvPr id="8" name="Shape 6"/>
           <p:cNvSpPr/>
           <p:nvPr/>
         </p:nvSpPr>
@@ -8673,7 +8863,7 @@
       </p:sp>
       <p:sp>
         <p:nvSpPr>
-          <p:cNvPr id="8" name="Shape 6"/>
+          <p:cNvPr id="9" name="Shape 7"/>
           <p:cNvSpPr/>
           <p:nvPr/>
         </p:nvSpPr>
@@ -8696,7 +8886,7 @@
       </p:sp>
       <p:sp>
         <p:nvSpPr>
-          <p:cNvPr id="9" name="Shape 7"/>
+          <p:cNvPr id="10" name="Shape 8"/>
           <p:cNvSpPr/>
           <p:nvPr/>
         </p:nvSpPr>
@@ -8719,7 +8909,7 @@
       </p:sp>
       <p:sp>
         <p:nvSpPr>
-          <p:cNvPr id="10" name="Shape 8"/>
+          <p:cNvPr id="11" name="Shape 9"/>
           <p:cNvSpPr/>
           <p:nvPr/>
         </p:nvSpPr>
@@ -8742,7 +8932,7 @@
       </p:sp>
       <p:sp>
         <p:nvSpPr>
-          <p:cNvPr id="11" name="Area Asuntos Electorales"/>
+          <p:cNvPr id="12" name="Area Asuntos Electorales"/>
           <p:cNvSpPr/>
           <p:nvPr/>
         </p:nvSpPr>
@@ -8769,7 +8959,7 @@
       </p:sp>
       <p:sp>
         <p:nvSpPr>
-          <p:cNvPr id="12" name="Text 10"/>
+          <p:cNvPr id="13" name="Text 11"/>
           <p:cNvSpPr txBox="1"/>
           <p:nvPr/>
         </p:nvSpPr>
@@ -8805,7 +8995,7 @@
       </p:sp>
       <p:sp>
         <p:nvSpPr>
-          <p:cNvPr id="13" name="Shape 11"/>
+          <p:cNvPr id="14" name="Shape 12"/>
           <p:cNvSpPr/>
           <p:nvPr/>
         </p:nvSpPr>
@@ -8828,7 +9018,7 @@
       </p:sp>
       <p:sp>
         <p:nvSpPr>
-          <p:cNvPr id="14" name="Area Tecnología y Datos"/>
+          <p:cNvPr id="15" name="Area Tecnología y Datos"/>
           <p:cNvSpPr/>
           <p:nvPr/>
         </p:nvSpPr>
@@ -8855,7 +9045,7 @@
       </p:sp>
       <p:sp>
         <p:nvSpPr>
-          <p:cNvPr id="15" name="Text 13"/>
+          <p:cNvPr id="16" name="Text 14"/>
           <p:cNvSpPr txBox="1"/>
           <p:nvPr/>
         </p:nvSpPr>
@@ -8891,7 +9081,7 @@
       </p:sp>
       <p:sp>
         <p:nvSpPr>
-          <p:cNvPr id="16" name="Shape 14"/>
+          <p:cNvPr id="17" name="Shape 15"/>
           <p:cNvSpPr/>
           <p:nvPr/>
         </p:nvSpPr>
@@ -8914,7 +9104,7 @@
       </p:sp>
       <p:sp>
         <p:nvSpPr>
-          <p:cNvPr id="17" name="Area Comunicaciones"/>
+          <p:cNvPr id="18" name="Area Comunicaciones"/>
           <p:cNvSpPr/>
           <p:nvPr/>
         </p:nvSpPr>
@@ -8941,7 +9131,7 @@
       </p:sp>
       <p:sp>
         <p:nvSpPr>
-          <p:cNvPr id="18" name="Text 16"/>
+          <p:cNvPr id="19" name="Text 17"/>
           <p:cNvSpPr txBox="1"/>
           <p:nvPr/>
         </p:nvSpPr>
@@ -8977,7 +9167,7 @@
       </p:sp>
       <p:sp>
         <p:nvSpPr>
-          <p:cNvPr id="19" name="Shape 17"/>
+          <p:cNvPr id="20" name="Shape 18"/>
           <p:cNvSpPr/>
           <p:nvPr/>
         </p:nvSpPr>
@@ -9000,7 +9190,7 @@
       </p:sp>
       <p:sp>
         <p:nvSpPr>
-          <p:cNvPr id="20" name="Area Logística y Movilización"/>
+          <p:cNvPr id="21" name="Area Logística y Movilización"/>
           <p:cNvSpPr/>
           <p:nvPr/>
         </p:nvSpPr>
@@ -9027,7 +9217,7 @@
       </p:sp>
       <p:sp>
         <p:nvSpPr>
-          <p:cNvPr id="21" name="Text 19"/>
+          <p:cNvPr id="22" name="Text 20"/>
           <p:cNvSpPr txBox="1"/>
           <p:nvPr/>
         </p:nvSpPr>
@@ -9063,7 +9253,7 @@
       </p:sp>
       <p:sp>
         <p:nvSpPr>
-          <p:cNvPr id="22" name="Shape 20"/>
+          <p:cNvPr id="23" name="Shape 21"/>
           <p:cNvSpPr/>
           <p:nvPr/>
         </p:nvSpPr>
@@ -9086,7 +9276,7 @@
       </p:sp>
       <p:sp>
         <p:nvSpPr>
-          <p:cNvPr id="23" name="Area Finanzas y Legal"/>
+          <p:cNvPr id="24" name="Area Finanzas y Legal"/>
           <p:cNvSpPr/>
           <p:nvPr/>
         </p:nvSpPr>
@@ -9113,7 +9303,7 @@
       </p:sp>
       <p:sp>
         <p:nvSpPr>
-          <p:cNvPr id="24" name="Text 22"/>
+          <p:cNvPr id="25" name="Text 23"/>
           <p:cNvSpPr txBox="1"/>
           <p:nvPr/>
         </p:nvSpPr>
@@ -9149,7 +9339,7 @@
       </p:sp>
       <p:sp>
         <p:nvSpPr>
-          <p:cNvPr id="25" name="Text 23"/>
+          <p:cNvPr id="26" name="Text 24"/>
           <p:cNvSpPr txBox="1"/>
           <p:nvPr/>
         </p:nvSpPr>
@@ -9185,7 +9375,7 @@
       </p:sp>
       <p:sp>
         <p:nvSpPr>
-          <p:cNvPr id="26" name="Text 24"/>
+          <p:cNvPr id="27" name="Text 25"/>
           <p:cNvSpPr txBox="1"/>
           <p:nvPr/>
         </p:nvSpPr>
@@ -9221,7 +9411,7 @@
       </p:sp>
       <p:sp>
         <p:nvSpPr>
-          <p:cNvPr id="27" name="Zona Phila. Noreste"/>
+          <p:cNvPr id="28" name="Zona Phila. Noreste"/>
           <p:cNvSpPr/>
           <p:nvPr/>
         </p:nvSpPr>
@@ -9248,7 +9438,7 @@
       </p:sp>
       <p:sp>
         <p:nvSpPr>
-          <p:cNvPr id="28" name="Text 26"/>
+          <p:cNvPr id="29" name="Text 27"/>
           <p:cNvSpPr txBox="1"/>
           <p:nvPr/>
         </p:nvSpPr>
@@ -9298,7 +9488,7 @@
       </p:sp>
       <p:sp>
         <p:nvSpPr>
-          <p:cNvPr id="29" name="Zona Phila. Kensington"/>
+          <p:cNvPr id="30" name="Zona Phila. Kensington"/>
           <p:cNvSpPr/>
           <p:nvPr/>
         </p:nvSpPr>
@@ -9325,7 +9515,7 @@
       </p:sp>
       <p:sp>
         <p:nvSpPr>
-          <p:cNvPr id="30" name="Text 28"/>
+          <p:cNvPr id="31" name="Text 29"/>
           <p:cNvSpPr txBox="1"/>
           <p:nvPr/>
         </p:nvSpPr>
@@ -9375,7 +9565,7 @@
       </p:sp>
       <p:sp>
         <p:nvSpPr>
-          <p:cNvPr id="31" name="Zona Reading"/>
+          <p:cNvPr id="32" name="Zona Reading"/>
           <p:cNvSpPr/>
           <p:nvPr/>
         </p:nvSpPr>
@@ -9402,7 +9592,7 @@
       </p:sp>
       <p:sp>
         <p:nvSpPr>
-          <p:cNvPr id="32" name="Text 30"/>
+          <p:cNvPr id="33" name="Text 31"/>
           <p:cNvSpPr txBox="1"/>
           <p:nvPr/>
         </p:nvSpPr>
@@ -9452,7 +9642,7 @@
       </p:sp>
       <p:sp>
         <p:nvSpPr>
-          <p:cNvPr id="33" name="Zona Allentown"/>
+          <p:cNvPr id="34" name="Zona Allentown"/>
           <p:cNvSpPr/>
           <p:nvPr/>
         </p:nvSpPr>
@@ -9479,7 +9669,7 @@
       </p:sp>
       <p:sp>
         <p:nvSpPr>
-          <p:cNvPr id="34" name="Text 32"/>
+          <p:cNvPr id="35" name="Text 33"/>
           <p:cNvSpPr txBox="1"/>
           <p:nvPr/>
         </p:nvSpPr>
@@ -9529,7 +9719,7 @@
       </p:sp>
       <p:sp>
         <p:nvSpPr>
-          <p:cNvPr id="35" name="Zona Hazleton"/>
+          <p:cNvPr id="36" name="Zona Hazleton"/>
           <p:cNvSpPr/>
           <p:nvPr/>
         </p:nvSpPr>
@@ -9556,7 +9746,7 @@
       </p:sp>
       <p:sp>
         <p:nvSpPr>
-          <p:cNvPr id="36" name="Text 34"/>
+          <p:cNvPr id="37" name="Text 35"/>
           <p:cNvSpPr txBox="1"/>
           <p:nvPr/>
         </p:nvSpPr>
@@ -9606,7 +9796,7 @@
       </p:sp>
       <p:sp>
         <p:nvSpPr>
-          <p:cNvPr id="37" name="Zona W-Barre / Scranton"/>
+          <p:cNvPr id="38" name="Zona W-Barre / Scranton"/>
           <p:cNvSpPr/>
           <p:nvPr/>
         </p:nvSpPr>
@@ -9633,7 +9823,7 @@
       </p:sp>
       <p:sp>
         <p:nvSpPr>
-          <p:cNvPr id="38" name="Text 36"/>
+          <p:cNvPr id="39" name="Text 37"/>
           <p:cNvSpPr txBox="1"/>
           <p:nvPr/>
         </p:nvSpPr>
@@ -9683,7 +9873,7 @@
       </p:sp>
       <p:sp>
         <p:nvSpPr>
-          <p:cNvPr id="39" name="Zona Harrisburg, Lancaster, York y Lebanon"/>
+          <p:cNvPr id="40" name="Zona Harrisburg, Lancaster, York y Lebanon"/>
           <p:cNvSpPr/>
           <p:nvPr/>
         </p:nvSpPr>
@@ -9710,7 +9900,7 @@
       </p:sp>
       <p:sp>
         <p:nvSpPr>
-          <p:cNvPr id="40" name="Text 38"/>
+          <p:cNvPr id="41" name="Text 39"/>
           <p:cNvSpPr txBox="1"/>
           <p:nvPr/>
         </p:nvSpPr>
@@ -9760,7 +9950,7 @@
       </p:sp>
       <p:sp>
         <p:nvSpPr>
-          <p:cNvPr id="41" name="Zona Delaware"/>
+          <p:cNvPr id="42" name="Zona Delaware"/>
           <p:cNvSpPr/>
           <p:nvPr/>
         </p:nvSpPr>
@@ -9787,7 +9977,7 @@
       </p:sp>
       <p:sp>
         <p:nvSpPr>
-          <p:cNvPr id="42" name="Text 40"/>
+          <p:cNvPr id="43" name="Text 41"/>
           <p:cNvSpPr txBox="1"/>
           <p:nvPr/>
         </p:nvSpPr>
@@ -9837,7 +10027,7 @@
       </p:sp>
       <p:sp>
         <p:nvSpPr>
-          <p:cNvPr id="43" name="Base"/>
+          <p:cNvPr id="44" name="Base"/>
           <p:cNvSpPr/>
           <p:nvPr/>
         </p:nvSpPr>
@@ -9864,7 +10054,7 @@
       </p:sp>
       <p:sp>
         <p:nvSpPr>
-          <p:cNvPr id="44" name="Text 42"/>
+          <p:cNvPr id="45" name="Text 43"/>
           <p:cNvSpPr txBox="1"/>
           <p:nvPr/>
         </p:nvSpPr>
@@ -9944,7 +10134,7 @@
       </p:sp>
       <p:sp>
         <p:nvSpPr>
-          <p:cNvPr id="46" name="Barra de navegación"/>
+          <p:cNvPr id="47" name="Barra de navegación"/>
           <p:cNvSpPr/>
           <p:nvPr/>
         </p:nvSpPr>
@@ -9969,7 +10159,7 @@
       </p:sp>
       <p:sp>
         <p:nvSpPr>
-          <p:cNvPr id="47" name="Shape 44"/>
+          <p:cNvPr id="48" name="Shape 45"/>
           <p:cNvSpPr/>
           <p:nvPr/>
         </p:nvSpPr>
@@ -9992,7 +10182,7 @@
       </p:sp>
       <p:sp>
         <p:nvSpPr>
-          <p:cNvPr id="48" name="Pestaña Diagnóstico"/>
+          <p:cNvPr id="49" name="Pestaña Diagnóstico"/>
           <p:cNvSpPr txBox="1"/>
           <p:nvPr/>
         </p:nvSpPr>
@@ -10035,7 +10225,7 @@
       </p:sp>
       <p:sp>
         <p:nvSpPr>
-          <p:cNvPr id="49" name="Pestaña Meta"/>
+          <p:cNvPr id="50" name="Pestaña Meta"/>
           <p:cNvSpPr txBox="1"/>
           <p:nvPr/>
         </p:nvSpPr>
@@ -10078,7 +10268,7 @@
       </p:sp>
       <p:sp>
         <p:nvSpPr>
-          <p:cNvPr id="50" name="Pestaña Plan y recomendación"/>
+          <p:cNvPr id="51" name="Pestaña Plan y recomendación"/>
           <p:cNvSpPr txBox="1"/>
           <p:nvPr/>
         </p:nvSpPr>
@@ -10114,7 +10304,7 @@
       </p:sp>
       <p:sp>
         <p:nvSpPr>
-          <p:cNvPr id="51" name="Sección actual"/>
+          <p:cNvPr id="52" name="Sección actual"/>
           <p:cNvSpPr/>
           <p:nvPr/>
         </p:nvSpPr>
@@ -10139,7 +10329,7 @@
       </p:sp>
       <p:sp>
         <p:nvSpPr>
-          <p:cNvPr id="52" name="Pestaña Ficha técnica"/>
+          <p:cNvPr id="53" name="Pestaña Ficha técnica"/>
           <p:cNvSpPr txBox="1"/>
           <p:nvPr/>
         </p:nvSpPr>
@@ -10252,7 +10442,45 @@
       </p:grpSpPr>
       <p:sp>
         <p:nvSpPr>
-          <p:cNvPr id="2" name="Text 1"/>
+          <p:cNvPr id="2" name="Marca de agua"/>
+          <p:cNvSpPr txBox="1"/>
+          <p:nvPr/>
+        </p:nvSpPr>
+        <p:spPr>
+          <a:xfrm rot="-1200000">
+            <a:off x="-320040" y="2743200"/>
+            <a:ext cx="12801600" cy="1097280"/>
+          </a:xfrm>
+          <a:prstGeom prst="rect">
+            <a:avLst/>
+          </a:prstGeom>
+          <a:noFill/>
+          <a:ln/>
+        </p:spPr>
+        <p:txBody>
+          <a:bodyPr wrap="none" lIns="0" tIns="0" rIns="0" bIns="0" rtlCol="0" anchor="ctr"/>
+          <a:lstStyle/>
+          <a:p>
+            <a:pPr algn="ctr" indent="0" marL="0">
+              <a:buNone/>
+            </a:pPr>
+            <a:r>
+              <a:rPr lang="en-US" sz="4400" b="1" spc="200" kern="0" dirty="0">
+                <a:solidFill>
+                  <a:srgbClr val="002B63">
+                    <a:alpha val="8000"/>
+                  </a:srgbClr>
+                </a:solidFill>
+              </a:rPr>
+              <a:t>CONFIDENCIAL · USO INTERNO DEL CAD</a:t>
+            </a:r>
+            <a:endParaRPr lang="en-US" sz="4400" dirty="0"/>
+          </a:p>
+        </p:txBody>
+      </p:sp>
+      <p:sp>
+        <p:nvSpPr>
+          <p:cNvPr id="3" name="Text 1"/>
           <p:cNvSpPr/>
           <p:nvPr>
             <p:ph idx="101" type="title" hasCustomPrompt="1"/>
@@ -10290,7 +10518,7 @@
       </p:sp>
       <p:sp>
         <p:nvSpPr>
-          <p:cNvPr id="3" name="Shape 1"/>
+          <p:cNvPr id="4" name="Shape 2"/>
           <p:cNvSpPr/>
           <p:nvPr/>
         </p:nvSpPr>
@@ -10315,7 +10543,7 @@
       </p:sp>
       <p:sp>
         <p:nvSpPr>
-          <p:cNvPr id="4" name="Text 2"/>
+          <p:cNvPr id="5" name="Text 3"/>
           <p:cNvSpPr txBox="1"/>
           <p:nvPr/>
         </p:nvSpPr>
@@ -10351,7 +10579,7 @@
       </p:sp>
       <p:sp>
         <p:nvSpPr>
-          <p:cNvPr id="5" name="Text 3"/>
+          <p:cNvPr id="6" name="Text 4"/>
           <p:cNvSpPr txBox="1"/>
           <p:nvPr/>
         </p:nvSpPr>
@@ -10401,7 +10629,7 @@
       </p:sp>
       <p:sp>
         <p:nvSpPr>
-          <p:cNvPr id="6" name="Shape 4"/>
+          <p:cNvPr id="7" name="Shape 5"/>
           <p:cNvSpPr/>
           <p:nvPr/>
         </p:nvSpPr>
@@ -10426,7 +10654,7 @@
       </p:sp>
       <p:sp>
         <p:nvSpPr>
-          <p:cNvPr id="7" name="Text 5"/>
+          <p:cNvPr id="8" name="Text 6"/>
           <p:cNvSpPr txBox="1"/>
           <p:nvPr/>
         </p:nvSpPr>
@@ -10462,7 +10690,7 @@
       </p:sp>
       <p:sp>
         <p:nvSpPr>
-          <p:cNvPr id="8" name="Text 6"/>
+          <p:cNvPr id="9" name="Text 7"/>
           <p:cNvSpPr txBox="1"/>
           <p:nvPr/>
         </p:nvSpPr>
@@ -10512,7 +10740,7 @@
       </p:sp>
       <p:sp>
         <p:nvSpPr>
-          <p:cNvPr id="9" name="Shape 7"/>
+          <p:cNvPr id="10" name="Shape 8"/>
           <p:cNvSpPr/>
           <p:nvPr/>
         </p:nvSpPr>
@@ -10537,7 +10765,7 @@
       </p:sp>
       <p:sp>
         <p:nvSpPr>
-          <p:cNvPr id="10" name="Text 8"/>
+          <p:cNvPr id="11" name="Text 9"/>
           <p:cNvSpPr txBox="1"/>
           <p:nvPr/>
         </p:nvSpPr>
@@ -10573,7 +10801,7 @@
       </p:sp>
       <p:sp>
         <p:nvSpPr>
-          <p:cNvPr id="11" name="Text 9"/>
+          <p:cNvPr id="12" name="Text 10"/>
           <p:cNvSpPr txBox="1"/>
           <p:nvPr/>
         </p:nvSpPr>
@@ -10623,7 +10851,7 @@
       </p:sp>
       <p:sp>
         <p:nvSpPr>
-          <p:cNvPr id="12" name="Shape 10"/>
+          <p:cNvPr id="13" name="Shape 11"/>
           <p:cNvSpPr/>
           <p:nvPr/>
         </p:nvSpPr>
@@ -10648,7 +10876,7 @@
       </p:sp>
       <p:sp>
         <p:nvSpPr>
-          <p:cNvPr id="13" name="Text 11"/>
+          <p:cNvPr id="14" name="Text 12"/>
           <p:cNvSpPr txBox="1"/>
           <p:nvPr/>
         </p:nvSpPr>
@@ -10684,7 +10912,7 @@
       </p:sp>
       <p:sp>
         <p:nvSpPr>
-          <p:cNvPr id="14" name="Text 12"/>
+          <p:cNvPr id="15" name="Text 13"/>
           <p:cNvSpPr txBox="1"/>
           <p:nvPr/>
         </p:nvSpPr>
@@ -10734,7 +10962,7 @@
       </p:sp>
       <p:sp>
         <p:nvSpPr>
-          <p:cNvPr id="15" name="Ruta 2028"/>
+          <p:cNvPr id="16" name="Ruta 2028"/>
           <p:cNvSpPr/>
           <p:nvPr/>
         </p:nvSpPr>
@@ -10761,7 +10989,7 @@
       </p:sp>
       <p:sp>
         <p:nvSpPr>
-          <p:cNvPr id="16" name="Text 14"/>
+          <p:cNvPr id="17" name="Text 15"/>
           <p:cNvSpPr txBox="1"/>
           <p:nvPr/>
         </p:nvSpPr>
@@ -10797,7 +11025,7 @@
       </p:sp>
       <p:sp>
         <p:nvSpPr>
-          <p:cNvPr id="17" name="Text 15"/>
+          <p:cNvPr id="18" name="Text 16"/>
           <p:cNvSpPr txBox="1"/>
           <p:nvPr/>
         </p:nvSpPr>
@@ -10858,7 +11086,7 @@
       </p:sp>
       <p:sp>
         <p:nvSpPr>
-          <p:cNvPr id="18" name="Text 16"/>
+          <p:cNvPr id="19" name="Text 17"/>
           <p:cNvSpPr txBox="1"/>
           <p:nvPr/>
         </p:nvSpPr>
@@ -10919,7 +11147,7 @@
       </p:sp>
       <p:sp>
         <p:nvSpPr>
-          <p:cNvPr id="19" name="Text 17"/>
+          <p:cNvPr id="20" name="Text 18"/>
           <p:cNvSpPr txBox="1"/>
           <p:nvPr/>
         </p:nvSpPr>
@@ -10980,7 +11208,7 @@
       </p:sp>
       <p:sp>
         <p:nvSpPr>
-          <p:cNvPr id="20" name="Text 18"/>
+          <p:cNvPr id="21" name="Text 19"/>
           <p:cNvSpPr txBox="1"/>
           <p:nvPr/>
         </p:nvSpPr>
@@ -11041,7 +11269,7 @@
       </p:sp>
       <p:sp>
         <p:nvSpPr>
-          <p:cNvPr id="22" name="Barra de navegación"/>
+          <p:cNvPr id="23" name="Barra de navegación"/>
           <p:cNvSpPr/>
           <p:nvPr/>
         </p:nvSpPr>
@@ -11066,7 +11294,7 @@
       </p:sp>
       <p:sp>
         <p:nvSpPr>
-          <p:cNvPr id="23" name="Shape 20"/>
+          <p:cNvPr id="24" name="Shape 21"/>
           <p:cNvSpPr/>
           <p:nvPr/>
         </p:nvSpPr>
@@ -11089,7 +11317,7 @@
       </p:sp>
       <p:sp>
         <p:nvSpPr>
-          <p:cNvPr id="24" name="Pestaña Diagnóstico"/>
+          <p:cNvPr id="25" name="Pestaña Diagnóstico"/>
           <p:cNvSpPr txBox="1"/>
           <p:nvPr/>
         </p:nvSpPr>
@@ -11132,7 +11360,7 @@
       </p:sp>
       <p:sp>
         <p:nvSpPr>
-          <p:cNvPr id="25" name="Pestaña Meta"/>
+          <p:cNvPr id="26" name="Pestaña Meta"/>
           <p:cNvSpPr txBox="1"/>
           <p:nvPr/>
         </p:nvSpPr>
@@ -11175,7 +11403,7 @@
       </p:sp>
       <p:sp>
         <p:nvSpPr>
-          <p:cNvPr id="26" name="Pestaña Plan y recomendación"/>
+          <p:cNvPr id="27" name="Pestaña Plan y recomendación"/>
           <p:cNvSpPr txBox="1"/>
           <p:nvPr/>
         </p:nvSpPr>
@@ -11211,7 +11439,7 @@
       </p:sp>
       <p:sp>
         <p:nvSpPr>
-          <p:cNvPr id="27" name="Sección actual"/>
+          <p:cNvPr id="28" name="Sección actual"/>
           <p:cNvSpPr/>
           <p:nvPr/>
         </p:nvSpPr>
@@ -11236,7 +11464,7 @@
       </p:sp>
       <p:sp>
         <p:nvSpPr>
-          <p:cNvPr id="28" name="Pestaña Ficha técnica"/>
+          <p:cNvPr id="29" name="Pestaña Ficha técnica"/>
           <p:cNvSpPr txBox="1"/>
           <p:nvPr/>
         </p:nvSpPr>
@@ -11349,7 +11577,45 @@
       </p:grpSpPr>
       <p:sp>
         <p:nvSpPr>
-          <p:cNvPr id="2" name="Titulo"/>
+          <p:cNvPr id="2" name="Marca de agua"/>
+          <p:cNvSpPr txBox="1"/>
+          <p:nvPr/>
+        </p:nvSpPr>
+        <p:spPr>
+          <a:xfrm rot="-1200000">
+            <a:off x="-320040" y="2743200"/>
+            <a:ext cx="12801600" cy="1097280"/>
+          </a:xfrm>
+          <a:prstGeom prst="rect">
+            <a:avLst/>
+          </a:prstGeom>
+          <a:noFill/>
+          <a:ln/>
+        </p:spPr>
+        <p:txBody>
+          <a:bodyPr wrap="none" lIns="0" tIns="0" rIns="0" bIns="0" rtlCol="0" anchor="ctr"/>
+          <a:lstStyle/>
+          <a:p>
+            <a:pPr algn="ctr" indent="0" marL="0">
+              <a:buNone/>
+            </a:pPr>
+            <a:r>
+              <a:rPr lang="en-US" sz="4400" b="1" spc="200" kern="0" dirty="0">
+                <a:solidFill>
+                  <a:srgbClr val="FFFFFF">
+                    <a:alpha val="10000"/>
+                  </a:srgbClr>
+                </a:solidFill>
+              </a:rPr>
+              <a:t>CONFIDENCIAL · USO INTERNO DEL CAD</a:t>
+            </a:r>
+            <a:endParaRPr lang="en-US" sz="4400" dirty="0"/>
+          </a:p>
+        </p:txBody>
+      </p:sp>
+      <p:sp>
+        <p:nvSpPr>
+          <p:cNvPr id="3" name="Titulo"/>
           <p:cNvSpPr txBox="1"/>
           <p:nvPr/>
         </p:nvSpPr>
@@ -11388,7 +11654,7 @@
       </p:sp>
       <p:sp>
         <p:nvSpPr>
-          <p:cNvPr id="3" name="Text 1"/>
+          <p:cNvPr id="4" name="Text 2"/>
           <p:cNvSpPr txBox="1"/>
           <p:nvPr/>
         </p:nvSpPr>
@@ -11424,7 +11690,7 @@
       </p:sp>
       <p:sp>
         <p:nvSpPr>
-          <p:cNvPr id="4" name="Shape 2"/>
+          <p:cNvPr id="5" name="Shape 3"/>
           <p:cNvSpPr/>
           <p:nvPr/>
         </p:nvSpPr>
@@ -11449,7 +11715,7 @@
       </p:sp>
       <p:pic>
         <p:nvPicPr>
-          <p:cNvPr id="5" name="Image 0" descr="preencoded.png">    </p:cNvPr>
+          <p:cNvPr id="6" name="Image 0" descr="preencoded.png">    </p:cNvPr>
           <p:cNvPicPr>
             <a:picLocks noChangeAspect="1"/>
           </p:cNvPicPr>
@@ -11473,7 +11739,7 @@
       </p:pic>
       <p:sp>
         <p:nvSpPr>
-          <p:cNvPr id="6" name="Text 3"/>
+          <p:cNvPr id="7" name="Text 4"/>
           <p:cNvSpPr txBox="1"/>
           <p:nvPr/>
         </p:nvSpPr>
@@ -11523,7 +11789,7 @@
       </p:sp>
       <p:sp>
         <p:nvSpPr>
-          <p:cNvPr id="7" name="Shape 4"/>
+          <p:cNvPr id="8" name="Shape 5"/>
           <p:cNvSpPr/>
           <p:nvPr/>
         </p:nvSpPr>
@@ -11548,7 +11814,7 @@
       </p:sp>
       <p:pic>
         <p:nvPicPr>
-          <p:cNvPr id="8" name="Image 1" descr="preencoded.png">    </p:cNvPr>
+          <p:cNvPr id="9" name="Image 1" descr="preencoded.png">    </p:cNvPr>
           <p:cNvPicPr>
             <a:picLocks noChangeAspect="1"/>
           </p:cNvPicPr>
@@ -11572,7 +11838,7 @@
       </p:pic>
       <p:sp>
         <p:nvSpPr>
-          <p:cNvPr id="9" name="Text 5"/>
+          <p:cNvPr id="10" name="Text 6"/>
           <p:cNvSpPr txBox="1"/>
           <p:nvPr/>
         </p:nvSpPr>
@@ -11622,7 +11888,7 @@
       </p:sp>
       <p:sp>
         <p:nvSpPr>
-          <p:cNvPr id="10" name="Shape 6"/>
+          <p:cNvPr id="11" name="Shape 7"/>
           <p:cNvSpPr/>
           <p:nvPr/>
         </p:nvSpPr>
@@ -11647,7 +11913,7 @@
       </p:sp>
       <p:pic>
         <p:nvPicPr>
-          <p:cNvPr id="11" name="Image 2" descr="preencoded.png">    </p:cNvPr>
+          <p:cNvPr id="12" name="Image 2" descr="preencoded.png">    </p:cNvPr>
           <p:cNvPicPr>
             <a:picLocks noChangeAspect="1"/>
           </p:cNvPicPr>
@@ -11671,7 +11937,7 @@
       </p:pic>
       <p:sp>
         <p:nvSpPr>
-          <p:cNvPr id="12" name="Text 7"/>
+          <p:cNvPr id="13" name="Text 8"/>
           <p:cNvSpPr txBox="1"/>
           <p:nvPr/>
         </p:nvSpPr>
@@ -11721,7 +11987,7 @@
       </p:sp>
       <p:sp>
         <p:nvSpPr>
-          <p:cNvPr id="13" name="Shape 8"/>
+          <p:cNvPr id="14" name="Shape 9"/>
           <p:cNvSpPr/>
           <p:nvPr/>
         </p:nvSpPr>
@@ -11746,7 +12012,7 @@
       </p:sp>
       <p:pic>
         <p:nvPicPr>
-          <p:cNvPr id="14" name="Image 3" descr="preencoded.png">    </p:cNvPr>
+          <p:cNvPr id="15" name="Image 3" descr="preencoded.png">    </p:cNvPr>
           <p:cNvPicPr>
             <a:picLocks noChangeAspect="1"/>
           </p:cNvPicPr>
@@ -11770,7 +12036,7 @@
       </p:pic>
       <p:sp>
         <p:nvSpPr>
-          <p:cNvPr id="15" name="Text 9"/>
+          <p:cNvPr id="16" name="Text 10"/>
           <p:cNvSpPr txBox="1"/>
           <p:nvPr/>
         </p:nvSpPr>
@@ -11820,7 +12086,7 @@
       </p:sp>
       <p:sp>
         <p:nvSpPr>
-          <p:cNvPr id="16" name="Shape 10"/>
+          <p:cNvPr id="17" name="Shape 11"/>
           <p:cNvSpPr/>
           <p:nvPr/>
         </p:nvSpPr>
@@ -11845,7 +12111,7 @@
       </p:sp>
       <p:pic>
         <p:nvPicPr>
-          <p:cNvPr id="17" name="Image 4" descr="preencoded.png">    </p:cNvPr>
+          <p:cNvPr id="18" name="Image 4" descr="preencoded.png">    </p:cNvPr>
           <p:cNvPicPr>
             <a:picLocks noChangeAspect="1"/>
           </p:cNvPicPr>
@@ -11869,7 +12135,7 @@
       </p:pic>
       <p:sp>
         <p:nvSpPr>
-          <p:cNvPr id="18" name="Text 11"/>
+          <p:cNvPr id="19" name="Text 12"/>
           <p:cNvSpPr txBox="1"/>
           <p:nvPr/>
         </p:nvSpPr>
@@ -11919,7 +12185,7 @@
       </p:sp>
       <p:sp>
         <p:nvSpPr>
-          <p:cNvPr id="19" name="Shape 12"/>
+          <p:cNvPr id="20" name="Shape 13"/>
           <p:cNvSpPr/>
           <p:nvPr/>
         </p:nvSpPr>
@@ -11944,7 +12210,7 @@
       </p:sp>
       <p:pic>
         <p:nvPicPr>
-          <p:cNvPr id="20" name="Image 5" descr="preencoded.png">    </p:cNvPr>
+          <p:cNvPr id="21" name="Image 5" descr="preencoded.png">    </p:cNvPr>
           <p:cNvPicPr>
             <a:picLocks noChangeAspect="1"/>
           </p:cNvPicPr>
@@ -11968,7 +12234,7 @@
       </p:pic>
       <p:sp>
         <p:nvSpPr>
-          <p:cNvPr id="21" name="Text 13"/>
+          <p:cNvPr id="22" name="Text 14"/>
           <p:cNvSpPr txBox="1"/>
           <p:nvPr/>
         </p:nvSpPr>
@@ -12018,7 +12284,7 @@
       </p:sp>
       <p:sp>
         <p:nvSpPr>
-          <p:cNvPr id="22" name="Shape 14"/>
+          <p:cNvPr id="23" name="Shape 15"/>
           <p:cNvSpPr/>
           <p:nvPr/>
         </p:nvSpPr>
@@ -12043,7 +12309,7 @@
       </p:sp>
       <p:pic>
         <p:nvPicPr>
-          <p:cNvPr id="23" name="Image 6" descr="preencoded.png">    </p:cNvPr>
+          <p:cNvPr id="24" name="Image 6" descr="preencoded.png">    </p:cNvPr>
           <p:cNvPicPr>
             <a:picLocks noChangeAspect="1"/>
           </p:cNvPicPr>
@@ -12067,7 +12333,7 @@
       </p:pic>
       <p:sp>
         <p:nvSpPr>
-          <p:cNvPr id="24" name="Text 15"/>
+          <p:cNvPr id="25" name="Text 16"/>
           <p:cNvSpPr txBox="1"/>
           <p:nvPr/>
         </p:nvSpPr>
@@ -12117,7 +12383,7 @@
       </p:sp>
       <p:sp>
         <p:nvSpPr>
-          <p:cNvPr id="26" name="Barra de navegación"/>
+          <p:cNvPr id="27" name="Barra de navegación"/>
           <p:cNvSpPr/>
           <p:nvPr/>
         </p:nvSpPr>
@@ -12142,7 +12408,7 @@
       </p:sp>
       <p:sp>
         <p:nvSpPr>
-          <p:cNvPr id="27" name="Shape 17"/>
+          <p:cNvPr id="28" name="Shape 18"/>
           <p:cNvSpPr/>
           <p:nvPr/>
         </p:nvSpPr>
@@ -12165,7 +12431,7 @@
       </p:sp>
       <p:sp>
         <p:nvSpPr>
-          <p:cNvPr id="28" name="Pestaña Diagnóstico"/>
+          <p:cNvPr id="29" name="Pestaña Diagnóstico"/>
           <p:cNvSpPr txBox="1"/>
           <p:nvPr/>
         </p:nvSpPr>
@@ -12208,7 +12474,7 @@
       </p:sp>
       <p:sp>
         <p:nvSpPr>
-          <p:cNvPr id="29" name="Pestaña Meta"/>
+          <p:cNvPr id="30" name="Pestaña Meta"/>
           <p:cNvSpPr txBox="1"/>
           <p:nvPr/>
         </p:nvSpPr>
@@ -12251,7 +12517,7 @@
       </p:sp>
       <p:sp>
         <p:nvSpPr>
-          <p:cNvPr id="30" name="Pestaña Plan y recomendación"/>
+          <p:cNvPr id="31" name="Pestaña Plan y recomendación"/>
           <p:cNvSpPr txBox="1"/>
           <p:nvPr/>
         </p:nvSpPr>
@@ -12287,7 +12553,7 @@
       </p:sp>
       <p:sp>
         <p:nvSpPr>
-          <p:cNvPr id="31" name="Sección actual"/>
+          <p:cNvPr id="32" name="Sección actual"/>
           <p:cNvSpPr/>
           <p:nvPr/>
         </p:nvSpPr>
@@ -12312,7 +12578,7 @@
       </p:sp>
       <p:sp>
         <p:nvSpPr>
-          <p:cNvPr id="32" name="Pestaña Ficha técnica"/>
+          <p:cNvPr id="33" name="Pestaña Ficha técnica"/>
           <p:cNvSpPr txBox="1"/>
           <p:nvPr/>
         </p:nvSpPr>
@@ -12425,7 +12691,45 @@
       </p:grpSpPr>
       <p:sp>
         <p:nvSpPr>
-          <p:cNvPr id="2" name="Text 1"/>
+          <p:cNvPr id="2" name="Marca de agua"/>
+          <p:cNvSpPr txBox="1"/>
+          <p:nvPr/>
+        </p:nvSpPr>
+        <p:spPr>
+          <a:xfrm rot="-1200000">
+            <a:off x="-320040" y="2743200"/>
+            <a:ext cx="12801600" cy="1097280"/>
+          </a:xfrm>
+          <a:prstGeom prst="rect">
+            <a:avLst/>
+          </a:prstGeom>
+          <a:noFill/>
+          <a:ln/>
+        </p:spPr>
+        <p:txBody>
+          <a:bodyPr wrap="none" lIns="0" tIns="0" rIns="0" bIns="0" rtlCol="0" anchor="ctr"/>
+          <a:lstStyle/>
+          <a:p>
+            <a:pPr algn="ctr" indent="0" marL="0">
+              <a:buNone/>
+            </a:pPr>
+            <a:r>
+              <a:rPr lang="en-US" sz="4400" b="1" spc="200" kern="0" dirty="0">
+                <a:solidFill>
+                  <a:srgbClr val="002B63">
+                    <a:alpha val="8000"/>
+                  </a:srgbClr>
+                </a:solidFill>
+              </a:rPr>
+              <a:t>CONFIDENCIAL · USO INTERNO DEL CAD</a:t>
+            </a:r>
+            <a:endParaRPr lang="en-US" sz="4400" dirty="0"/>
+          </a:p>
+        </p:txBody>
+      </p:sp>
+      <p:sp>
+        <p:nvSpPr>
+          <p:cNvPr id="3" name="Text 1"/>
           <p:cNvSpPr/>
           <p:nvPr>
             <p:ph idx="101" type="title" hasCustomPrompt="1"/>
@@ -12463,7 +12767,7 @@
       </p:sp>
       <p:sp>
         <p:nvSpPr>
-          <p:cNvPr id="3" name="Cifra 1"/>
+          <p:cNvPr id="4" name="Cifra 1"/>
           <p:cNvSpPr/>
           <p:nvPr/>
         </p:nvSpPr>
@@ -12490,7 +12794,7 @@
       </p:sp>
       <p:sp>
         <p:nvSpPr>
-          <p:cNvPr id="4" name="Text 2"/>
+          <p:cNvPr id="5" name="Text 3"/>
           <p:cNvSpPr txBox="1"/>
           <p:nvPr/>
         </p:nvSpPr>
@@ -12540,7 +12844,7 @@
       </p:sp>
       <p:sp>
         <p:nvSpPr>
-          <p:cNvPr id="5" name="Cifra 2"/>
+          <p:cNvPr id="6" name="Cifra 2"/>
           <p:cNvSpPr/>
           <p:nvPr/>
         </p:nvSpPr>
@@ -12567,7 +12871,7 @@
       </p:sp>
       <p:sp>
         <p:nvSpPr>
-          <p:cNvPr id="6" name="Text 4"/>
+          <p:cNvPr id="7" name="Text 5"/>
           <p:cNvSpPr txBox="1"/>
           <p:nvPr/>
         </p:nvSpPr>
@@ -12617,7 +12921,7 @@
       </p:sp>
       <p:sp>
         <p:nvSpPr>
-          <p:cNvPr id="7" name="Cifra 3"/>
+          <p:cNvPr id="8" name="Cifra 3"/>
           <p:cNvSpPr/>
           <p:nvPr/>
         </p:nvSpPr>
@@ -12644,7 +12948,7 @@
       </p:sp>
       <p:sp>
         <p:nvSpPr>
-          <p:cNvPr id="8" name="Text 6"/>
+          <p:cNvPr id="9" name="Text 7"/>
           <p:cNvSpPr txBox="1"/>
           <p:nvPr/>
         </p:nvSpPr>
@@ -12694,7 +12998,7 @@
       </p:sp>
       <p:sp>
         <p:nvSpPr>
-          <p:cNvPr id="9" name="El problema"/>
+          <p:cNvPr id="10" name="El problema"/>
           <p:cNvSpPr/>
           <p:nvPr/>
         </p:nvSpPr>
@@ -12721,7 +13025,7 @@
       </p:sp>
       <p:sp>
         <p:nvSpPr>
-          <p:cNvPr id="10" name="Text 8"/>
+          <p:cNvPr id="11" name="Text 9"/>
           <p:cNvSpPr txBox="1"/>
           <p:nvPr/>
         </p:nvSpPr>
@@ -12757,7 +13061,7 @@
       </p:sp>
       <p:sp>
         <p:nvSpPr>
-          <p:cNvPr id="11" name="Text 9"/>
+          <p:cNvPr id="12" name="Text 10"/>
           <p:cNvSpPr txBox="1"/>
           <p:nvPr/>
         </p:nvSpPr>
@@ -12793,7 +13097,7 @@
       </p:sp>
       <p:sp>
         <p:nvSpPr>
-          <p:cNvPr id="12" name="El plan"/>
+          <p:cNvPr id="13" name="El plan"/>
           <p:cNvSpPr/>
           <p:nvPr/>
         </p:nvSpPr>
@@ -12820,7 +13124,7 @@
       </p:sp>
       <p:sp>
         <p:nvSpPr>
-          <p:cNvPr id="13" name="Text 11"/>
+          <p:cNvPr id="14" name="Text 12"/>
           <p:cNvSpPr txBox="1"/>
           <p:nvPr/>
         </p:nvSpPr>
@@ -12856,7 +13160,7 @@
       </p:sp>
       <p:sp>
         <p:nvSpPr>
-          <p:cNvPr id="14" name="Text 12"/>
+          <p:cNvPr id="15" name="Text 13"/>
           <p:cNvSpPr txBox="1"/>
           <p:nvPr/>
         </p:nvSpPr>
@@ -12892,7 +13196,7 @@
       </p:sp>
       <p:sp>
         <p:nvSpPr>
-          <p:cNvPr id="15" name="La meta"/>
+          <p:cNvPr id="16" name="La meta"/>
           <p:cNvSpPr/>
           <p:nvPr/>
         </p:nvSpPr>
@@ -12919,7 +13223,7 @@
       </p:sp>
       <p:sp>
         <p:nvSpPr>
-          <p:cNvPr id="16" name="Text 14"/>
+          <p:cNvPr id="17" name="Text 15"/>
           <p:cNvSpPr txBox="1"/>
           <p:nvPr/>
         </p:nvSpPr>
@@ -12955,7 +13259,7 @@
       </p:sp>
       <p:sp>
         <p:nvSpPr>
-          <p:cNvPr id="17" name="Text 15"/>
+          <p:cNvPr id="18" name="Text 16"/>
           <p:cNvSpPr txBox="1"/>
           <p:nvPr/>
         </p:nvSpPr>
@@ -12991,7 +13295,7 @@
       </p:sp>
       <p:sp>
         <p:nvSpPr>
-          <p:cNvPr id="18" name="Próximo paso"/>
+          <p:cNvPr id="19" name="Próximo paso"/>
           <p:cNvSpPr/>
           <p:nvPr/>
         </p:nvSpPr>
@@ -13018,7 +13322,7 @@
       </p:sp>
       <p:sp>
         <p:nvSpPr>
-          <p:cNvPr id="19" name="Text 17"/>
+          <p:cNvPr id="20" name="Text 18"/>
           <p:cNvSpPr txBox="1"/>
           <p:nvPr/>
         </p:nvSpPr>
@@ -13054,7 +13358,7 @@
       </p:sp>
       <p:sp>
         <p:nvSpPr>
-          <p:cNvPr id="20" name="Text 18"/>
+          <p:cNvPr id="21" name="Text 19"/>
           <p:cNvSpPr txBox="1"/>
           <p:nvPr/>
         </p:nvSpPr>
@@ -13090,7 +13394,7 @@
       </p:sp>
       <p:sp>
         <p:nvSpPr>
-          <p:cNvPr id="21" name="Fuente"/>
+          <p:cNvPr id="22" name="Fuente"/>
           <p:cNvSpPr txBox="1"/>
           <p:nvPr/>
         </p:nvSpPr>
@@ -13126,7 +13430,7 @@
       </p:sp>
       <p:sp>
         <p:nvSpPr>
-          <p:cNvPr id="23" name="Barra de navegación"/>
+          <p:cNvPr id="24" name="Barra de navegación"/>
           <p:cNvSpPr/>
           <p:nvPr/>
         </p:nvSpPr>
@@ -13151,7 +13455,7 @@
       </p:sp>
       <p:sp>
         <p:nvSpPr>
-          <p:cNvPr id="24" name="Shape 21"/>
+          <p:cNvPr id="25" name="Shape 22"/>
           <p:cNvSpPr/>
           <p:nvPr/>
         </p:nvSpPr>
@@ -13174,7 +13478,7 @@
       </p:sp>
       <p:sp>
         <p:nvSpPr>
-          <p:cNvPr id="25" name="Pestaña Diagnóstico"/>
+          <p:cNvPr id="26" name="Pestaña Diagnóstico"/>
           <p:cNvSpPr txBox="1"/>
           <p:nvPr/>
         </p:nvSpPr>
@@ -13217,7 +13521,7 @@
       </p:sp>
       <p:sp>
         <p:nvSpPr>
-          <p:cNvPr id="26" name="Pestaña Meta"/>
+          <p:cNvPr id="27" name="Pestaña Meta"/>
           <p:cNvSpPr txBox="1"/>
           <p:nvPr/>
         </p:nvSpPr>
@@ -13260,7 +13564,7 @@
       </p:sp>
       <p:sp>
         <p:nvSpPr>
-          <p:cNvPr id="27" name="Pestaña Plan y recomendación"/>
+          <p:cNvPr id="28" name="Pestaña Plan y recomendación"/>
           <p:cNvSpPr txBox="1"/>
           <p:nvPr/>
         </p:nvSpPr>
@@ -13296,7 +13600,7 @@
       </p:sp>
       <p:sp>
         <p:nvSpPr>
-          <p:cNvPr id="28" name="Sección actual"/>
+          <p:cNvPr id="29" name="Sección actual"/>
           <p:cNvSpPr/>
           <p:nvPr/>
         </p:nvSpPr>
@@ -13321,7 +13625,7 @@
       </p:sp>
       <p:sp>
         <p:nvSpPr>
-          <p:cNvPr id="29" name="Pestaña Ficha técnica"/>
+          <p:cNvPr id="30" name="Pestaña Ficha técnica"/>
           <p:cNvSpPr txBox="1"/>
           <p:nvPr/>
         </p:nvSpPr>
@@ -13434,7 +13738,45 @@
       </p:grpSpPr>
       <p:sp>
         <p:nvSpPr>
-          <p:cNvPr id="2" name="Text 1"/>
+          <p:cNvPr id="2" name="Marca de agua"/>
+          <p:cNvSpPr txBox="1"/>
+          <p:nvPr/>
+        </p:nvSpPr>
+        <p:spPr>
+          <a:xfrm rot="-1200000">
+            <a:off x="-320040" y="2743200"/>
+            <a:ext cx="12801600" cy="1097280"/>
+          </a:xfrm>
+          <a:prstGeom prst="rect">
+            <a:avLst/>
+          </a:prstGeom>
+          <a:noFill/>
+          <a:ln/>
+        </p:spPr>
+        <p:txBody>
+          <a:bodyPr wrap="none" lIns="0" tIns="0" rIns="0" bIns="0" rtlCol="0" anchor="ctr"/>
+          <a:lstStyle/>
+          <a:p>
+            <a:pPr algn="ctr" indent="0" marL="0">
+              <a:buNone/>
+            </a:pPr>
+            <a:r>
+              <a:rPr lang="en-US" sz="4400" b="1" spc="200" kern="0" dirty="0">
+                <a:solidFill>
+                  <a:srgbClr val="002B63">
+                    <a:alpha val="8000"/>
+                  </a:srgbClr>
+                </a:solidFill>
+              </a:rPr>
+              <a:t>CONFIDENCIAL · USO INTERNO DEL CAD</a:t>
+            </a:r>
+            <a:endParaRPr lang="en-US" sz="4400" dirty="0"/>
+          </a:p>
+        </p:txBody>
+      </p:sp>
+      <p:sp>
+        <p:nvSpPr>
+          <p:cNvPr id="3" name="Text 1"/>
           <p:cNvSpPr/>
           <p:nvPr>
             <p:ph idx="101" type="title" hasCustomPrompt="1"/>
@@ -13472,7 +13814,7 @@
       </p:sp>
       <p:sp>
         <p:nvSpPr>
-          <p:cNvPr id="3" name="Ficha Fuentes de datos"/>
+          <p:cNvPr id="4" name="Ficha Fuentes de datos"/>
           <p:cNvSpPr/>
           <p:nvPr/>
         </p:nvSpPr>
@@ -13499,7 +13841,7 @@
       </p:sp>
       <p:sp>
         <p:nvSpPr>
-          <p:cNvPr id="4" name="Text 2"/>
+          <p:cNvPr id="5" name="Text 3"/>
           <p:cNvSpPr txBox="1"/>
           <p:nvPr/>
         </p:nvSpPr>
@@ -13535,7 +13877,7 @@
       </p:sp>
       <p:sp>
         <p:nvSpPr>
-          <p:cNvPr id="5" name="Text 3"/>
+          <p:cNvPr id="6" name="Text 4"/>
           <p:cNvSpPr txBox="1"/>
           <p:nvPr/>
         </p:nvSpPr>
@@ -13629,7 +13971,7 @@
       </p:sp>
       <p:sp>
         <p:nvSpPr>
-          <p:cNvPr id="6" name="Ficha Método"/>
+          <p:cNvPr id="7" name="Ficha Método"/>
           <p:cNvSpPr/>
           <p:nvPr/>
         </p:nvSpPr>
@@ -13656,7 +13998,7 @@
       </p:sp>
       <p:sp>
         <p:nvSpPr>
-          <p:cNvPr id="7" name="Text 5"/>
+          <p:cNvPr id="8" name="Text 6"/>
           <p:cNvSpPr txBox="1"/>
           <p:nvPr/>
         </p:nvSpPr>
@@ -13692,7 +14034,7 @@
       </p:sp>
       <p:sp>
         <p:nvSpPr>
-          <p:cNvPr id="8" name="Text 6"/>
+          <p:cNvPr id="9" name="Text 7"/>
           <p:cNvSpPr txBox="1"/>
           <p:nvPr/>
         </p:nvSpPr>
@@ -13786,7 +14128,7 @@
       </p:sp>
       <p:sp>
         <p:nvSpPr>
-          <p:cNvPr id="9" name="Ficha Supuestos y notas"/>
+          <p:cNvPr id="10" name="Ficha Supuestos y notas"/>
           <p:cNvSpPr/>
           <p:nvPr/>
         </p:nvSpPr>
@@ -13813,7 +14155,7 @@
       </p:sp>
       <p:sp>
         <p:nvSpPr>
-          <p:cNvPr id="10" name="Text 8"/>
+          <p:cNvPr id="11" name="Text 9"/>
           <p:cNvSpPr txBox="1"/>
           <p:nvPr/>
         </p:nvSpPr>
@@ -13849,7 +14191,7 @@
       </p:sp>
       <p:sp>
         <p:nvSpPr>
-          <p:cNvPr id="11" name="Text 9"/>
+          <p:cNvPr id="12" name="Text 10"/>
           <p:cNvSpPr txBox="1"/>
           <p:nvPr/>
         </p:nvSpPr>
@@ -13943,7 +14285,7 @@
       </p:sp>
       <p:sp>
         <p:nvSpPr>
-          <p:cNvPr id="12" name="Text 10"/>
+          <p:cNvPr id="13" name="Text 11"/>
           <p:cNvSpPr txBox="1"/>
           <p:nvPr/>
         </p:nvSpPr>
@@ -13990,7 +14332,7 @@
       </p:sp>
       <p:sp>
         <p:nvSpPr>
-          <p:cNvPr id="14" name="Barra de navegación"/>
+          <p:cNvPr id="15" name="Barra de navegación"/>
           <p:cNvSpPr/>
           <p:nvPr/>
         </p:nvSpPr>
@@ -14015,7 +14357,7 @@
       </p:sp>
       <p:sp>
         <p:nvSpPr>
-          <p:cNvPr id="15" name="Shape 12"/>
+          <p:cNvPr id="16" name="Shape 13"/>
           <p:cNvSpPr/>
           <p:nvPr/>
         </p:nvSpPr>
@@ -14038,7 +14380,7 @@
       </p:sp>
       <p:sp>
         <p:nvSpPr>
-          <p:cNvPr id="16" name="Pestaña Diagnóstico"/>
+          <p:cNvPr id="17" name="Pestaña Diagnóstico"/>
           <p:cNvSpPr txBox="1"/>
           <p:nvPr/>
         </p:nvSpPr>
@@ -14081,7 +14423,7 @@
       </p:sp>
       <p:sp>
         <p:nvSpPr>
-          <p:cNvPr id="17" name="Pestaña Meta"/>
+          <p:cNvPr id="18" name="Pestaña Meta"/>
           <p:cNvSpPr txBox="1"/>
           <p:nvPr/>
         </p:nvSpPr>
@@ -14124,7 +14466,7 @@
       </p:sp>
       <p:sp>
         <p:nvSpPr>
-          <p:cNvPr id="18" name="Pestaña Plan y recomendación"/>
+          <p:cNvPr id="19" name="Pestaña Plan y recomendación"/>
           <p:cNvSpPr txBox="1"/>
           <p:nvPr/>
         </p:nvSpPr>
@@ -14167,7 +14509,7 @@
       </p:sp>
       <p:sp>
         <p:nvSpPr>
-          <p:cNvPr id="19" name="Pestaña Ficha técnica"/>
+          <p:cNvPr id="20" name="Pestaña Ficha técnica"/>
           <p:cNvSpPr txBox="1"/>
           <p:nvPr/>
         </p:nvSpPr>
@@ -14203,7 +14545,7 @@
       </p:sp>
       <p:sp>
         <p:nvSpPr>
-          <p:cNvPr id="20" name="Sección actual"/>
+          <p:cNvPr id="21" name="Sección actual"/>
           <p:cNvSpPr/>
           <p:nvPr/>
         </p:nvSpPr>

</xml_diff>

<commit_message>
Ficha técnica: asignación de colegios a recintos confirmada con la seccional
Co-Authored-By: Claude Opus 5.5 <noreply@anthropic.com>
Claude-Session: https://claude.ai/code/session_01RrEJtrwRidXxzgveZEVQjf
</commit_message>
<xml_diff>
--- a/presentaciones/Plan_Estrategico_Electoral_Pennsylvania_2028.pptx
+++ b/presentaciones/Plan_Estrategico_Electoral_Pennsylvania_2028.pptx
@@ -115,19 +115,19 @@
   <p:extLst>
     <p:ext uri="{521415D9-36F7-43E2-AB2F-B90AF26B5E84}">
       <p14:sectionLst xmlns:p14="http://schemas.microsoft.com/office/powerpoint/2010/main">
-        <p14:section name="Diagnóstico" id="{d23820ea-5169-ae62-a496-a2245df8f1b9}">
+        <p14:section name="Diagnóstico" id="{d55c8c30-2a3f-cb48-6cad-05146945bf57}">
           <p14:sldIdLst>
             <p14:sldId id="256"/>
             <p14:sldId id="257"/>
             <p14:sldId id="258"/>
           </p14:sldIdLst>
         </p14:section>
-        <p14:section name="Meta" id="{fb9bcf24-d6dd-faf0-b022-0cd9b7ce23a0}">
+        <p14:section name="Meta" id="{af0dcdac-2aa5-5c79-facb-424f8d3a118d}">
           <p14:sldIdLst>
             <p14:sldId id="259"/>
           </p14:sldIdLst>
         </p14:section>
-        <p14:section name="Plan y recomendación" id="{e65f8ddf-a990-3898-c37e-4bb2110ce87f}">
+        <p14:section name="Plan y recomendación" id="{a205e567-5bd7-046a-0d82-5600a2e4d24b}">
           <p14:sldIdLst>
             <p14:sldId id="260"/>
             <p14:sldId id="261"/>
@@ -135,7 +135,7 @@
             <p14:sldId id="263"/>
           </p14:sldIdLst>
         </p14:section>
-        <p14:section name="Ficha técnica" id="{417704cb-7c17-9122-959b-186ddcfa4640}">
+        <p14:section name="Ficha técnica" id="{9e0639b9-3ed9-72ba-3cbd-b1565e55da62}">
           <p14:sldIdLst>
             <p14:sldId id="264"/>
           </p14:sldIdLst>
@@ -14277,7 +14277,7 @@
                   <a:schemeClr val="tx1"/>
                 </a:solidFill>
               </a:rPr>
-              <a:t>El colegio 1259 se asignó a la Asociación de Pennsylvania (Reading) por numeración; pendiente de confirmar</a:t>
+              <a:t>Asignación de los 84 colegios a sus recintos confirmada con la Seccional PRM Pennsylvania</a:t>
             </a:r>
             <a:endParaRPr lang="en-US" sz="1300" dirty="0"/>
           </a:p>

</xml_diff>

<commit_message>
Diapositiva 5 interactiva: líderes por zona según los inscritos del simulador
En la versión web, la estructura muestra los líderes calculados para los
inscritos elegidos en la diapositiva 4 (8 variantes, elegidas por CSS).
En PPTX y PDF, el subtítulo aclara que son los líderes con el padrón actual.

Co-Authored-By: Claude Opus 5.5 <noreply@anthropic.com>
Claude-Session: https://claude.ai/code/session_01RrEJtrwRidXxzgveZEVQjf
</commit_message>
<xml_diff>
--- a/presentaciones/Plan_Estrategico_Electoral_Pennsylvania_2028.pptx
+++ b/presentaciones/Plan_Estrategico_Electoral_Pennsylvania_2028.pptx
@@ -115,19 +115,19 @@
   <p:extLst>
     <p:ext uri="{521415D9-36F7-43E2-AB2F-B90AF26B5E84}">
       <p14:sectionLst xmlns:p14="http://schemas.microsoft.com/office/powerpoint/2010/main">
-        <p14:section name="Diagnóstico" id="{d55c8c30-2a3f-cb48-6cad-05146945bf57}">
+        <p14:section name="Diagnóstico" id="{91a76df9-5fe8-bf9c-1ee8-208e22408fa5}">
           <p14:sldIdLst>
             <p14:sldId id="256"/>
             <p14:sldId id="257"/>
             <p14:sldId id="258"/>
           </p14:sldIdLst>
         </p14:section>
-        <p14:section name="Meta" id="{af0dcdac-2aa5-5c79-facb-424f8d3a118d}">
+        <p14:section name="Meta" id="{486c7e51-3daa-bb10-e402-e86248f19759}">
           <p14:sldIdLst>
             <p14:sldId id="259"/>
           </p14:sldIdLst>
         </p14:section>
-        <p14:section name="Plan y recomendación" id="{a205e567-5bd7-046a-0d82-5600a2e4d24b}">
+        <p14:section name="Plan y recomendación" id="{315be213-0fd6-32a7-d880-b11a87dee50a}">
           <p14:sldIdLst>
             <p14:sldId id="260"/>
             <p14:sldId id="261"/>
@@ -135,7 +135,7 @@
             <p14:sldId id="263"/>
           </p14:sldIdLst>
         </p14:section>
-        <p14:section name="Ficha técnica" id="{9e0639b9-3ed9-72ba-3cbd-b1565e55da62}">
+        <p14:section name="Ficha técnica" id="{92a87ed1-d9df-9741-e983-1879b9be90a3}">
           <p14:sldIdLst>
             <p14:sldId id="264"/>
           </p14:sldIdLst>
@@ -9403,7 +9403,7 @@
                   <a:schemeClr val="tx2"/>
                 </a:solidFill>
               </a:rPr>
-              <a:t>8 coordinadores de zona · líderes que necesita cada zona</a:t>
+              <a:t>8 coordinadores de zona · líderes por zona con el padrón actual (47,529)</a:t>
             </a:r>
             <a:endParaRPr lang="en-US" sz="1300" dirty="0"/>
           </a:p>

</xml_diff>

<commit_message>
Los 47,529 inscritos se presentan como dato de 2024, con el padrón 2028 por construir
Diapositiva 2: título y cifra en pasado (2024) y nuevo recuadro sobre la
renovación de cédulas. Diapositivas 5 y de resumen: «padrón de 2024».

Co-Authored-By: Claude Opus 5.5 <noreply@anthropic.com>
Claude-Session: https://claude.ai/code/session_01RrEJtrwRidXxzgveZEVQjf
</commit_message>
<xml_diff>
--- a/presentaciones/Plan_Estrategico_Electoral_Pennsylvania_2028.pptx
+++ b/presentaciones/Plan_Estrategico_Electoral_Pennsylvania_2028.pptx
@@ -115,19 +115,19 @@
   <p:extLst>
     <p:ext uri="{521415D9-36F7-43E2-AB2F-B90AF26B5E84}">
       <p14:sectionLst xmlns:p14="http://schemas.microsoft.com/office/powerpoint/2010/main">
-        <p14:section name="Diagnóstico" id="{91a76df9-5fe8-bf9c-1ee8-208e22408fa5}">
+        <p14:section name="Diagnóstico" id="{d44b3acc-fa1a-ff09-7f1a-64ef8327e87a}">
           <p14:sldIdLst>
             <p14:sldId id="256"/>
             <p14:sldId id="257"/>
             <p14:sldId id="258"/>
           </p14:sldIdLst>
         </p14:section>
-        <p14:section name="Meta" id="{486c7e51-3daa-bb10-e402-e86248f19759}">
+        <p14:section name="Meta" id="{5543e979-260c-764e-c51c-d01b50114343}">
           <p14:sldIdLst>
             <p14:sldId id="259"/>
           </p14:sldIdLst>
         </p14:section>
-        <p14:section name="Plan y recomendación" id="{315be213-0fd6-32a7-d880-b11a87dee50a}">
+        <p14:section name="Plan y recomendación" id="{6308dedf-955e-36f8-34c5-185bdbfa830d}">
           <p14:sldIdLst>
             <p14:sldId id="260"/>
             <p14:sldId id="261"/>
@@ -135,7 +135,7 @@
             <p14:sldId id="263"/>
           </p14:sldIdLst>
         </p14:section>
-        <p14:section name="Ficha técnica" id="{92a87ed1-d9df-9741-e983-1879b9be90a3}">
+        <p14:section name="Ficha técnica" id="{e9d80923-298f-4921-a3b9-950fde5d1426}">
           <p14:sldIdLst>
             <p14:sldId id="264"/>
           </p14:sldIdLst>
@@ -3785,7 +3785,7 @@
                   <a:schemeClr val="tx2"/>
                 </a:solidFill>
               </a:rPr>
-              <a:t>Pennsylvania tiene 227,647 dominicanos y solo 47,529 están inscritos para votar aquí: el potencial es enorme</a:t>
+              <a:t>Pennsylvania tiene 227,647 dominicanos y en 2024 solo 47,529 estaban inscritos: el nuevo padrón está por hacerse</a:t>
             </a:r>
             <a:endParaRPr lang="en-US" sz="2800" dirty="0"/>
           </a:p>
@@ -3878,7 +3878,7 @@
                   <a:schemeClr val="tx1"/>
                 </a:solidFill>
               </a:rPr>
-              <a:t>dominicanos del estado está inscrito para votar en la seccional (21 %). Y la comunidad creció un 26 % desde 2022</a:t>
+              <a:t>dominicanos del estado estaba inscrito para votar en la seccional en 2024 (21 %). Y la comunidad creció un 26 % desde 2022</a:t>
             </a:r>
             <a:endParaRPr lang="en-US" sz="2200" dirty="0"/>
           </a:p>
@@ -3963,7 +3963,7 @@
       </p:sp>
       <p:sp>
         <p:nvSpPr>
-          <p:cNvPr id="9" name="Dos tramites"/>
+          <p:cNvPr id="9" name="Padron 2028"/>
           <p:cNvSpPr/>
           <p:nvPr/>
         </p:nvSpPr>
@@ -4018,7 +4018,7 @@
                   <a:schemeClr val="bg1"/>
                 </a:solidFill>
               </a:rPr>
-              <a:t>Dos trámites, una sola cita</a:t>
+              <a:t>Padrón 2028: todavía por construir</a:t>
             </a:r>
             <a:endParaRPr lang="en-US" sz="1800" dirty="0"/>
           </a:p>
@@ -4032,7 +4032,7 @@
                   <a:schemeClr val="bg1"/>
                 </a:solidFill>
               </a:rPr>
-              <a:t>Cédula nueva + domicilio electoral en Pennsylvania. Aprovechar la renovación para hacer ambos (confirmar con la JCE).</a:t>
+              <a:t>Con la renovación de cédulas aún no se sabe cuántos podrán votar. Cada cita es la oportunidad de sacar la cédula nueva e inscribir el domicilio en Pennsylvania (confirmar con la JCE).</a:t>
             </a:r>
             <a:endParaRPr lang="en-US" sz="1800" dirty="0"/>
           </a:p>
@@ -9403,7 +9403,7 @@
                   <a:schemeClr val="tx2"/>
                 </a:solidFill>
               </a:rPr>
-              <a:t>8 coordinadores de zona · líderes por zona con el padrón actual (47,529)</a:t>
+              <a:t>8 coordinadores de zona · líderes por zona con el padrón de 2024 (47,529)</a:t>
             </a:r>
             <a:endParaRPr lang="en-US" sz="1300" dirty="0"/>
           </a:p>
@@ -12836,7 +12836,7 @@
                   <a:schemeClr val="accent4"/>
                 </a:solidFill>
               </a:rPr>
-              <a:t>electores en 13 ciudades</a:t>
+              <a:t>inscritos en 2024 (13 ciudades)</a:t>
             </a:r>
             <a:endParaRPr lang="en-US" sz="3400" dirty="0"/>
           </a:p>

</xml_diff>

<commit_message>
Red de líderes calculada desde la meta; portada con el padrón de 2024
La red debe aportar 3,400 votos (55 % de la meta). Líderes = 3,400 / (10 x %
de comprometidos que vota) / 0.8 (margen del 20 %): 607 con 70 %. Reparto
por zona según el potencial (abstención 2024 x voto del PRM y aliados).
Los inscritos ya no cambian la red. En la web, el porcentaje (60/70/85 %) se
elige en el simulador y cambia la diapositiva 5 y el mapa. Cifras de la red
actualizadas en mapa, meta, 30 días, resumen y ficha técnica.

Portada: «En 2024, de 47,529 electores solo votaron 8,939» y «(2024)» en el
recuadro de la 4.ª seccional.

Co-Authored-By: Claude Opus 5.5 <noreply@anthropic.com>
Claude-Session: https://claude.ai/code/session_01RrEJtrwRidXxzgveZEVQjf
</commit_message>
<xml_diff>
--- a/presentaciones/Plan_Estrategico_Electoral_Pennsylvania_2028.pptx
+++ b/presentaciones/Plan_Estrategico_Electoral_Pennsylvania_2028.pptx
@@ -115,19 +115,19 @@
   <p:extLst>
     <p:ext uri="{521415D9-36F7-43E2-AB2F-B90AF26B5E84}">
       <p14:sectionLst xmlns:p14="http://schemas.microsoft.com/office/powerpoint/2010/main">
-        <p14:section name="Diagnóstico" id="{d44b3acc-fa1a-ff09-7f1a-64ef8327e87a}">
+        <p14:section name="Diagnóstico" id="{33123de4-dce2-5665-8e9d-1c21b81a3914}">
           <p14:sldIdLst>
             <p14:sldId id="256"/>
             <p14:sldId id="257"/>
             <p14:sldId id="258"/>
           </p14:sldIdLst>
         </p14:section>
-        <p14:section name="Meta" id="{5543e979-260c-764e-c51c-d01b50114343}">
+        <p14:section name="Meta" id="{6fa48fea-50c5-850a-6adf-7f10b71070c1}">
           <p14:sldIdLst>
             <p14:sldId id="259"/>
           </p14:sldIdLst>
         </p14:section>
-        <p14:section name="Plan y recomendación" id="{6308dedf-955e-36f8-34c5-185bdbfa830d}">
+        <p14:section name="Plan y recomendación" id="{43e8f222-7b72-1ba0-0955-ac6992d2e34a}">
           <p14:sldIdLst>
             <p14:sldId id="260"/>
             <p14:sldId id="261"/>
@@ -135,7 +135,7 @@
             <p14:sldId id="263"/>
           </p14:sldIdLst>
         </p14:section>
-        <p14:section name="Ficha técnica" id="{e9d80923-298f-4921-a3b9-950fde5d1426}">
+        <p14:section name="Ficha técnica" id="{a6d5f488-b148-1f5e-a506-e7db0af32db5}">
           <p14:sldIdLst>
             <p14:sldId id="264"/>
           </p14:sldIdLst>
@@ -1803,7 +1803,7 @@
           <a:p>
             <a:r>
               <a:rPr lang="en-US" dirty="0"/>
-              <a:t>Plan de arranque de 30 días con entregables verificables. Ritmo de la meta: 400 líderes en unas 13 semanas, unos 31 por semana; si en la semana 4 hay menos de 90 líderes, se reasignan recursos y se replanifica. Después siguen las 4 etapas hasta mayo de 2028. La fecha legal de primarias es el 3 de octubre de 2027.</a:t>
+              <a:t>Plan de arranque de 30 días con entregables verificables. Ritmo de la meta: 607 líderes en unas 13 semanas, unos 47 por semana; si en la semana 4 hay menos de 140 líderes, se reasignan recursos y se replanifica. Después siguen las 4 etapas hasta mayo de 2028. La fecha legal de primarias es el 3 de octubre de 2027.</a:t>
             </a:r>
             <a:endParaRPr lang="en-US" dirty="0"/>
           </a:p>
@@ -1979,7 +1979,7 @@
           <a:p>
             <a:r>
               <a:rPr lang="en-US" dirty="0"/>
-              <a:t>Esta es la diapositiva para quien solo lea una. Problema: participación de 18.8 % (8,939 de 47,529, dato oficial JCE) y riesgo de la nueva cédula. Plan: 8 zonas, 400 líderes con 10 personas cada uno (4,000 personas). Meta: 6,140 votos para David Collado, un 10 % más que los 5,581 votos del PRM y aliados en 2024 (63.4 % de los válidos). Próximo paso: nombrar coordinadores e iniciar en noviembre.</a:t>
+              <a:t>Esta es la diapositiva para quien solo lea una. Problema: participación de 18.8 % (8,939 de 47,529, dato oficial JCE) y riesgo de la nueva cédula. Plan: 8 zonas, 607 líderes con 10 personas cada uno, con 20 % de margen (4,857 votantes comprometidos que, si vota el 70 %, aportan unos 3,400 votos). Meta: 6,140 votos para David Collado, un 10 % más que los 5,581 votos del PRM y aliados en 2024 (63.4 % de los válidos). Próximo paso: nombrar coordinadores e iniciar en noviembre.</a:t>
             </a:r>
             <a:endParaRPr lang="en-US" dirty="0"/>
           </a:p>
@@ -2975,7 +2975,7 @@
                 <a:ea typeface="Calibri" pitchFamily="34" charset="-122"/>
                 <a:cs typeface="Calibri" pitchFamily="34" charset="-120"/>
               </a:rPr>
-              <a:t>47,529 electores, solo 8,939 votaron: 8 de cada 10 se quedaron en casa</a:t>
+              <a:t>En 2024, de 47,529 electores solo votaron 8,939: 8 de cada 10 se quedaron en casa</a:t>
             </a:r>
             <a:endParaRPr lang="en-US" sz="3800" dirty="0"/>
           </a:p>
@@ -3203,7 +3203,7 @@
                   <a:schemeClr val="accent4"/>
                 </a:solidFill>
               </a:rPr>
-              <a:t>seccional más grande de la Circunscripción I</a:t>
+              <a:t>seccional más grande de la Circunscripción I (2024)</a:t>
             </a:r>
             <a:endParaRPr lang="en-US" sz="3000" dirty="0"/>
           </a:p>
@@ -6183,7 +6183,7 @@
                   <a:schemeClr val="accent2"/>
                 </a:solidFill>
               </a:rPr>
-              <a:t>81</a:t>
+              <a:t>126</a:t>
             </a:r>
             <a:endParaRPr lang="en-US" sz="1800" dirty="0"/>
           </a:p>
@@ -6330,7 +6330,7 @@
                   <a:schemeClr val="accent2"/>
                 </a:solidFill>
               </a:rPr>
-              <a:t>55</a:t>
+              <a:t>89</a:t>
             </a:r>
             <a:endParaRPr lang="en-US" sz="1800" dirty="0"/>
           </a:p>
@@ -6477,7 +6477,7 @@
                   <a:schemeClr val="accent2"/>
                 </a:solidFill>
               </a:rPr>
-              <a:t>70</a:t>
+              <a:t>100</a:t>
             </a:r>
             <a:endParaRPr lang="en-US" sz="1800" dirty="0"/>
           </a:p>
@@ -6624,7 +6624,7 @@
                   <a:schemeClr val="accent2"/>
                 </a:solidFill>
               </a:rPr>
-              <a:t>69</a:t>
+              <a:t>101</a:t>
             </a:r>
             <a:endParaRPr lang="en-US" sz="1800" dirty="0"/>
           </a:p>
@@ -6771,7 +6771,7 @@
                   <a:schemeClr val="accent2"/>
                 </a:solidFill>
               </a:rPr>
-              <a:t>55</a:t>
+              <a:t>87</a:t>
             </a:r>
             <a:endParaRPr lang="en-US" sz="1800" dirty="0"/>
           </a:p>
@@ -6918,7 +6918,7 @@
                   <a:schemeClr val="accent2"/>
                 </a:solidFill>
               </a:rPr>
-              <a:t>15</a:t>
+              <a:t>24</a:t>
             </a:r>
             <a:endParaRPr lang="en-US" sz="1800" dirty="0"/>
           </a:p>
@@ -7065,7 +7065,7 @@
                   <a:schemeClr val="accent2"/>
                 </a:solidFill>
               </a:rPr>
-              <a:t>46</a:t>
+              <a:t>66</a:t>
             </a:r>
             <a:endParaRPr lang="en-US" sz="1800" dirty="0"/>
           </a:p>
@@ -7212,7 +7212,7 @@
                   <a:schemeClr val="accent2"/>
                 </a:solidFill>
               </a:rPr>
-              <a:t>9</a:t>
+              <a:t>14</a:t>
             </a:r>
             <a:endParaRPr lang="en-US" sz="1800" dirty="0"/>
           </a:p>
@@ -7684,7 +7684,7 @@
                   <a:schemeClr val="tx2"/>
                 </a:solidFill>
               </a:rPr>
-              <a:t>Red de 4,000 votantes comprometidos: </a:t>
+              <a:t>Red de 4,857 votantes comprometidos: </a:t>
             </a:r>
             <a:pPr indent="0" marL="0">
               <a:buNone/>
@@ -7695,7 +7695,7 @@
                   <a:schemeClr val="tx1"/>
                 </a:solidFill>
               </a:rPr>
-              <a:t>si vota el 85 %, son unos 3,400 votos, el 55 % de la meta.</a:t>
+              <a:t>si vota el 70 %, son unos 3,400 votos, el 55 % de la meta.</a:t>
             </a:r>
             <a:endParaRPr lang="en-US" sz="1400" dirty="0"/>
           </a:p>
@@ -9403,7 +9403,7 @@
                   <a:schemeClr val="tx2"/>
                 </a:solidFill>
               </a:rPr>
-              <a:t>8 coordinadores de zona · líderes por zona con el padrón de 2024 (47,529)</a:t>
+              <a:t>8 coordinadores de zona · líderes por zona, con 20 % de margen (si vota el 70 % de los comprometidos)</a:t>
             </a:r>
             <a:endParaRPr lang="en-US" sz="1300" dirty="0"/>
           </a:p>
@@ -9466,7 +9466,7 @@
                   <a:schemeClr val="accent2"/>
                 </a:solidFill>
               </a:rPr>
-              <a:t>81</a:t>
+              <a:t>126</a:t>
             </a:r>
             <a:endParaRPr lang="en-US" sz="2200" dirty="0"/>
           </a:p>
@@ -9543,7 +9543,7 @@
                   <a:schemeClr val="accent2"/>
                 </a:solidFill>
               </a:rPr>
-              <a:t>55</a:t>
+              <a:t>89</a:t>
             </a:r>
             <a:endParaRPr lang="en-US" sz="2200" dirty="0"/>
           </a:p>
@@ -9620,7 +9620,7 @@
                   <a:schemeClr val="accent2"/>
                 </a:solidFill>
               </a:rPr>
-              <a:t>70</a:t>
+              <a:t>100</a:t>
             </a:r>
             <a:endParaRPr lang="en-US" sz="2200" dirty="0"/>
           </a:p>
@@ -9697,7 +9697,7 @@
                   <a:schemeClr val="accent2"/>
                 </a:solidFill>
               </a:rPr>
-              <a:t>69</a:t>
+              <a:t>101</a:t>
             </a:r>
             <a:endParaRPr lang="en-US" sz="2200" dirty="0"/>
           </a:p>
@@ -9774,7 +9774,7 @@
                   <a:schemeClr val="accent2"/>
                 </a:solidFill>
               </a:rPr>
-              <a:t>55</a:t>
+              <a:t>87</a:t>
             </a:r>
             <a:endParaRPr lang="en-US" sz="2200" dirty="0"/>
           </a:p>
@@ -9851,7 +9851,7 @@
                   <a:schemeClr val="accent2"/>
                 </a:solidFill>
               </a:rPr>
-              <a:t>15</a:t>
+              <a:t>24</a:t>
             </a:r>
             <a:endParaRPr lang="en-US" sz="2200" dirty="0"/>
           </a:p>
@@ -9928,7 +9928,7 @@
                   <a:schemeClr val="accent2"/>
                 </a:solidFill>
               </a:rPr>
-              <a:t>46</a:t>
+              <a:t>66</a:t>
             </a:r>
             <a:endParaRPr lang="en-US" sz="2200" dirty="0"/>
           </a:p>
@@ -10005,7 +10005,7 @@
                   <a:schemeClr val="accent2"/>
                 </a:solidFill>
               </a:rPr>
-              <a:t>9</a:t>
+              <a:t>14</a:t>
             </a:r>
             <a:endParaRPr lang="en-US" sz="2200" dirty="0"/>
           </a:p>
@@ -10082,7 +10082,7 @@
                   <a:schemeClr val="bg1"/>
                 </a:solidFill>
               </a:rPr>
-              <a:t>400 líderes</a:t>
+              <a:t>607 líderes</a:t>
             </a:r>
             <a:pPr algn="ctr" indent="0" marL="0">
               <a:buNone/>
@@ -10104,7 +10104,29 @@
                   <a:schemeClr val="bg1"/>
                 </a:solidFill>
               </a:rPr>
-              <a:t>4,000 votantes comprometidos (≈ 3,400 votos)</a:t>
+              <a:t>4,857 votantes comprometidos</a:t>
+            </a:r>
+            <a:pPr algn="ctr" indent="0" marL="0">
+              <a:buNone/>
+            </a:pPr>
+            <a:r>
+              <a:rPr lang="en-US" sz="1600" dirty="0">
+                <a:solidFill>
+                  <a:schemeClr val="accent4"/>
+                </a:solidFill>
+              </a:rPr>
+              <a:t>   →   </a:t>
+            </a:r>
+            <a:pPr algn="ctr" indent="0" marL="0">
+              <a:buNone/>
+            </a:pPr>
+            <a:r>
+              <a:rPr lang="en-US" sz="1600" b="1" dirty="0">
+                <a:solidFill>
+                  <a:schemeClr val="bg1"/>
+                </a:solidFill>
+              </a:rPr>
+              <a:t>≈ 3,400 votos</a:t>
             </a:r>
             <a:pPr algn="ctr" indent="0" marL="0">
               <a:buNone/>
@@ -10954,7 +10976,7 @@
                   <a:schemeClr val="tx1"/>
                 </a:solidFill>
               </a:rPr>
-              <a:t>Primer corte del tablero por zona: al menos 90 líderes reclutados; informe a la dirección de campaña</a:t>
+              <a:t>Primer corte del tablero por zona: al menos 140 líderes reclutados; informe a la dirección de campaña</a:t>
             </a:r>
             <a:endParaRPr lang="en-US" sz="1600" dirty="0"/>
           </a:p>
@@ -11139,7 +11161,7 @@
                   <a:schemeClr val="tx1"/>
                 </a:solidFill>
               </a:rPr>
-              <a:t>400 líderes y 4,000 personas; 60 % del padrón renovado; recién llegados trasladados</a:t>
+              <a:t>607 líderes y 4,857 comprometidos; 60 % del padrón renovado; recién llegados trasladados</a:t>
             </a:r>
             <a:endParaRPr lang="en-US" sz="1400" dirty="0"/>
           </a:p>
@@ -12759,7 +12781,7 @@
                   <a:schemeClr val="tx2"/>
                 </a:solidFill>
               </a:rPr>
-              <a:t>Resumen: con 8 zonas y una red de 4,000 votantes, David Collado puede superar en 10 % al PRM y aliados de 2024</a:t>
+              <a:t>Resumen: con 8 zonas y una red de 607 líderes, David Collado puede superar en 10 % al PRM y aliados de 2024</a:t>
             </a:r>
             <a:endParaRPr lang="en-US" sz="2800" dirty="0"/>
           </a:p>
@@ -13188,7 +13210,7 @@
                   <a:schemeClr val="tx1"/>
                 </a:solidFill>
               </a:rPr>
-              <a:t>8 zonas, 8 coordinadores y 400 líderes con 10 personas cada uno. La cédula y el traslado de los recién llegados son la puerta de entrada.</a:t>
+              <a:t>8 zonas, 8 coordinadores y 607 líderes con 10 personas cada uno (incluye 20 % de margen). La cédula y el traslado son la puerta de entrada.</a:t>
             </a:r>
             <a:endParaRPr lang="en-US" sz="1500" dirty="0"/>
           </a:p>
@@ -14120,7 +14142,7 @@
                   <a:schemeClr val="tx1"/>
                 </a:solidFill>
               </a:rPr>
-              <a:t>Zonas: agrupación geográfica propuesta de las 13 ciudades; líderes repartidos según los electores</a:t>
+              <a:t>Zonas: agrupación geográfica propuesta de las 13 ciudades; líderes repartidos según el potencial (abstención 2024 × voto del PRM y aliados)</a:t>
             </a:r>
             <a:endParaRPr lang="en-US" sz="1300" dirty="0"/>
           </a:p>
@@ -14241,7 +14263,7 @@
                   <a:schemeClr val="tx1"/>
                 </a:solidFill>
               </a:rPr>
-              <a:t>Red: 400 líderes con 10 personas cada uno; se estima que vota el 85 %</a:t>
+              <a:t>Red: aporta 3,400 votos (55 % de la meta); vota el 70 % de los comprometidos; 10 por líder y 20 % de margen = 607 líderes</a:t>
             </a:r>
             <a:endParaRPr lang="en-US" sz="1300" dirty="0"/>
           </a:p>

</xml_diff>

<commit_message>
Portada: la 4.ª seccional más grande de la Circunscripción I es dato de 2026
Co-Authored-By: Claude Opus 5.5 <noreply@anthropic.com>
Claude-Session: https://claude.ai/code/session_01RrEJtrwRidXxzgveZEVQjf
</commit_message>
<xml_diff>
--- a/presentaciones/Plan_Estrategico_Electoral_Pennsylvania_2028.pptx
+++ b/presentaciones/Plan_Estrategico_Electoral_Pennsylvania_2028.pptx
@@ -115,19 +115,19 @@
   <p:extLst>
     <p:ext uri="{521415D9-36F7-43E2-AB2F-B90AF26B5E84}">
       <p14:sectionLst xmlns:p14="http://schemas.microsoft.com/office/powerpoint/2010/main">
-        <p14:section name="Diagnóstico" id="{33123de4-dce2-5665-8e9d-1c21b81a3914}">
+        <p14:section name="Diagnóstico" id="{a50eff6c-a816-16bd-2448-47e78a28a2e7}">
           <p14:sldIdLst>
             <p14:sldId id="256"/>
             <p14:sldId id="257"/>
             <p14:sldId id="258"/>
           </p14:sldIdLst>
         </p14:section>
-        <p14:section name="Meta" id="{6fa48fea-50c5-850a-6adf-7f10b71070c1}">
+        <p14:section name="Meta" id="{9ce0d5b6-5574-cec8-e67d-2d355164ccfb}">
           <p14:sldIdLst>
             <p14:sldId id="259"/>
           </p14:sldIdLst>
         </p14:section>
-        <p14:section name="Plan y recomendación" id="{43e8f222-7b72-1ba0-0955-ac6992d2e34a}">
+        <p14:section name="Plan y recomendación" id="{d50dba61-b2ce-9575-13ce-a5061c0cc1a2}">
           <p14:sldIdLst>
             <p14:sldId id="260"/>
             <p14:sldId id="261"/>
@@ -135,7 +135,7 @@
             <p14:sldId id="263"/>
           </p14:sldIdLst>
         </p14:section>
-        <p14:section name="Ficha técnica" id="{a6d5f488-b148-1f5e-a506-e7db0af32db5}">
+        <p14:section name="Ficha técnica" id="{e34d0581-d66e-74c3-06bb-c7823dcf794e}">
           <p14:sldIdLst>
             <p14:sldId id="264"/>
           </p14:sldIdLst>
@@ -1363,7 +1363,7 @@
           <a:p>
             <a:r>
               <a:rPr lang="en-US" dirty="0"/>
-              <a:t>La OCLEE Philadelphia es en realidad la Seccional Pennsylvania: incluye 12 ciudades de Pennsylvania y Wilmington (Delaware). 47,529 electores en 84 mesas (padrón de la seccional; la JCE divulgó 47,604 en el corte preliminar). Votos 2024, dato oficial JCE a nivel presidencial: 8,939 emitidos (8,810 válidos y 129 nulos). Participación: 18.8 %; no votaron 38,590. Es la 4.ª seccional más grande de la Circunscripción I, después de Nueva York, Nueva Jersey y Boston; según el INDEX, Pennsylvania tuvo en 2025 el mayor aumento de dominicanos de EE. UU. (+36,553).</a:t>
+              <a:t>La OCLEE Philadelphia es en realidad la Seccional Pennsylvania: incluye 12 ciudades de Pennsylvania y Wilmington (Delaware). 47,529 electores en 84 mesas (padrón de la seccional; la JCE divulgó 47,604 en el corte preliminar). Votos 2024, dato oficial JCE a nivel presidencial: 8,939 emitidos (8,810 válidos y 129 nulos). Participación: 18.8 %; no votaron 38,590. Es la 4.ª seccional más grande de la Circunscripción I (dato de 2026), después de Nueva York, Nueva Jersey y Boston; según el INDEX, Pennsylvania tuvo en 2025 el mayor aumento de dominicanos de EE. UU. (+36,553).</a:t>
             </a:r>
             <a:endParaRPr lang="en-US" dirty="0"/>
           </a:p>
@@ -3203,7 +3203,7 @@
                   <a:schemeClr val="accent4"/>
                 </a:solidFill>
               </a:rPr>
-              <a:t>seccional más grande de la Circunscripción I (2024)</a:t>
+              <a:t>seccional más grande de la Circunscripción I (2026)</a:t>
             </a:r>
             <a:endParaRPr lang="en-US" sz="3000" dirty="0"/>
           </a:p>

</xml_diff>

<commit_message>
Red de líderes: distinguir líderes activos y reserva
«607 líderes (486 activos + reserva)» en la diapositiva 5 y en el simulador,
para que la cifra cuadre con los 4,857 comprometidos.

Co-Authored-By: Claude Opus 5.5 <noreply@anthropic.com>
Claude-Session: https://claude.ai/code/session_01RrEJtrwRidXxzgveZEVQjf
</commit_message>
<xml_diff>
--- a/presentaciones/Plan_Estrategico_Electoral_Pennsylvania_2028.pptx
+++ b/presentaciones/Plan_Estrategico_Electoral_Pennsylvania_2028.pptx
@@ -115,19 +115,19 @@
   <p:extLst>
     <p:ext uri="{521415D9-36F7-43E2-AB2F-B90AF26B5E84}">
       <p14:sectionLst xmlns:p14="http://schemas.microsoft.com/office/powerpoint/2010/main">
-        <p14:section name="Diagnóstico" id="{a50eff6c-a816-16bd-2448-47e78a28a2e7}">
+        <p14:section name="Diagnóstico" id="{e19bd426-c41b-1f4c-4c46-a9ee89e5fd04}">
           <p14:sldIdLst>
             <p14:sldId id="256"/>
             <p14:sldId id="257"/>
             <p14:sldId id="258"/>
           </p14:sldIdLst>
         </p14:section>
-        <p14:section name="Meta" id="{9ce0d5b6-5574-cec8-e67d-2d355164ccfb}">
+        <p14:section name="Meta" id="{b3376abf-b379-4db4-47a3-d060aaad0277}">
           <p14:sldIdLst>
             <p14:sldId id="259"/>
           </p14:sldIdLst>
         </p14:section>
-        <p14:section name="Plan y recomendación" id="{d50dba61-b2ce-9575-13ce-a5061c0cc1a2}">
+        <p14:section name="Plan y recomendación" id="{96b45ea8-9b6a-6088-acf7-e01dc7990b8d}">
           <p14:sldIdLst>
             <p14:sldId id="260"/>
             <p14:sldId id="261"/>
@@ -135,7 +135,7 @@
             <p14:sldId id="263"/>
           </p14:sldIdLst>
         </p14:section>
-        <p14:section name="Ficha técnica" id="{e34d0581-d66e-74c3-06bb-c7823dcf794e}">
+        <p14:section name="Ficha técnica" id="{d807d673-09ab-b5d2-6f36-c339bf7a05b4}">
           <p14:sldIdLst>
             <p14:sldId id="264"/>
           </p14:sldIdLst>
@@ -10083,6 +10083,17 @@
                 </a:solidFill>
               </a:rPr>
               <a:t>607 líderes</a:t>
+            </a:r>
+            <a:pPr algn="ctr" indent="0" marL="0">
+              <a:buNone/>
+            </a:pPr>
+            <a:r>
+              <a:rPr lang="en-US" sz="1600" dirty="0">
+                <a:solidFill>
+                  <a:schemeClr val="bg1"/>
+                </a:solidFill>
+              </a:rPr>
+              <a:t> (486 activos + reserva)</a:t>
             </a:r>
             <a:pPr algn="ctr" indent="0" marL="0">
               <a:buNone/>

</xml_diff>

<commit_message>
Vuelve a «607 líderes → 4,857 votantes comprometidos» sin el desglose de activos
Co-Authored-By: Claude Opus 5.5 <noreply@anthropic.com>
Claude-Session: https://claude.ai/code/session_01RrEJtrwRidXxzgveZEVQjf
</commit_message>
<xml_diff>
--- a/presentaciones/Plan_Estrategico_Electoral_Pennsylvania_2028.pptx
+++ b/presentaciones/Plan_Estrategico_Electoral_Pennsylvania_2028.pptx
@@ -115,19 +115,19 @@
   <p:extLst>
     <p:ext uri="{521415D9-36F7-43E2-AB2F-B90AF26B5E84}">
       <p14:sectionLst xmlns:p14="http://schemas.microsoft.com/office/powerpoint/2010/main">
-        <p14:section name="Diagnóstico" id="{e19bd426-c41b-1f4c-4c46-a9ee89e5fd04}">
+        <p14:section name="Diagnóstico" id="{b5744be6-3193-1ec5-33ac-9b2947af91ee}">
           <p14:sldIdLst>
             <p14:sldId id="256"/>
             <p14:sldId id="257"/>
             <p14:sldId id="258"/>
           </p14:sldIdLst>
         </p14:section>
-        <p14:section name="Meta" id="{b3376abf-b379-4db4-47a3-d060aaad0277}">
+        <p14:section name="Meta" id="{c33bfa0e-5827-9373-d177-f2c71a16dc53}">
           <p14:sldIdLst>
             <p14:sldId id="259"/>
           </p14:sldIdLst>
         </p14:section>
-        <p14:section name="Plan y recomendación" id="{96b45ea8-9b6a-6088-acf7-e01dc7990b8d}">
+        <p14:section name="Plan y recomendación" id="{f56da133-ed5c-7832-c2c1-54b4d4dde60f}">
           <p14:sldIdLst>
             <p14:sldId id="260"/>
             <p14:sldId id="261"/>
@@ -135,7 +135,7 @@
             <p14:sldId id="263"/>
           </p14:sldIdLst>
         </p14:section>
-        <p14:section name="Ficha técnica" id="{d807d673-09ab-b5d2-6f36-c339bf7a05b4}">
+        <p14:section name="Ficha técnica" id="{7a173f47-76e6-2fcd-13ad-3f5b09e8eb10}">
           <p14:sldIdLst>
             <p14:sldId id="264"/>
           </p14:sldIdLst>
@@ -10083,17 +10083,6 @@
                 </a:solidFill>
               </a:rPr>
               <a:t>607 líderes</a:t>
-            </a:r>
-            <a:pPr algn="ctr" indent="0" marL="0">
-              <a:buNone/>
-            </a:pPr>
-            <a:r>
-              <a:rPr lang="en-US" sz="1600" dirty="0">
-                <a:solidFill>
-                  <a:schemeClr val="bg1"/>
-                </a:solidFill>
-              </a:rPr>
-              <a:t> (486 activos + reserva)</a:t>
             </a:r>
             <a:pPr algn="ctr" indent="0" marL="0">
               <a:buNone/>

</xml_diff>

<commit_message>
Portada «Herramienta en desarrollo» y marca de agua «Confidencial · Uso interno»
Para presentarlo al equipo local de Pennsylvania: la etiqueta de la portada
deja de decir «Propuesta para el CAD» y la marca de agua deja de nombrar al
CAD, en PPTX, PDF y web.

Co-Authored-By: Claude Opus 5.5 <noreply@anthropic.com>
Claude-Session: https://claude.ai/code/session_01RrEJtrwRidXxzgveZEVQjf
</commit_message>
<xml_diff>
--- a/presentaciones/Plan_Estrategico_Electoral_Pennsylvania_2028.pptx
+++ b/presentaciones/Plan_Estrategico_Electoral_Pennsylvania_2028.pptx
@@ -115,19 +115,19 @@
   <p:extLst>
     <p:ext uri="{521415D9-36F7-43E2-AB2F-B90AF26B5E84}">
       <p14:sectionLst xmlns:p14="http://schemas.microsoft.com/office/powerpoint/2010/main">
-        <p14:section name="Diagnóstico" id="{b5744be6-3193-1ec5-33ac-9b2947af91ee}">
+        <p14:section name="Diagnóstico" id="{5634c04b-abe6-5130-6a50-b1141d229d3d}">
           <p14:sldIdLst>
             <p14:sldId id="256"/>
             <p14:sldId id="257"/>
             <p14:sldId id="258"/>
           </p14:sldIdLst>
         </p14:section>
-        <p14:section name="Meta" id="{c33bfa0e-5827-9373-d177-f2c71a16dc53}">
+        <p14:section name="Meta" id="{3162e062-7fcf-42ba-f36b-fdabbe8316fc}">
           <p14:sldIdLst>
             <p14:sldId id="259"/>
           </p14:sldIdLst>
         </p14:section>
-        <p14:section name="Plan y recomendación" id="{f56da133-ed5c-7832-c2c1-54b4d4dde60f}">
+        <p14:section name="Plan y recomendación" id="{7c57a9ee-70e5-1a9b-9b5b-c67f7f96a7ea}">
           <p14:sldIdLst>
             <p14:sldId id="260"/>
             <p14:sldId id="261"/>
@@ -135,7 +135,7 @@
             <p14:sldId id="263"/>
           </p14:sldIdLst>
         </p14:section>
-        <p14:section name="Ficha técnica" id="{7a173f47-76e6-2fcd-13ad-3f5b09e8eb10}">
+        <p14:section name="Ficha técnica" id="{b1ce9185-da7c-8df9-856a-f2992b253912}">
           <p14:sldIdLst>
             <p14:sldId id="264"/>
           </p14:sldIdLst>
@@ -2777,7 +2777,7 @@
                   </a:srgbClr>
                 </a:solidFill>
               </a:rPr>
-              <a:t>CONFIDENCIAL · USO INTERNO DEL CAD</a:t>
+              <a:t>CONFIDENCIAL · USO INTERNO</a:t>
             </a:r>
             <a:endParaRPr lang="en-US" sz="4400" dirty="0"/>
           </a:p>
@@ -2925,7 +2925,7 @@
                   <a:schemeClr val="bg1"/>
                 </a:solidFill>
               </a:rPr>
-              <a:t>PROPUESTA PARA EL CAD</a:t>
+              <a:t>HERRAMIENTA EN DESARROLLO</a:t>
             </a:r>
             <a:pPr algn="ctr" indent="0" marL="0">
               <a:buNone/>
@@ -3747,7 +3747,7 @@
                   </a:srgbClr>
                 </a:solidFill>
               </a:rPr>
-              <a:t>CONFIDENCIAL · USO INTERNO DEL CAD</a:t>
+              <a:t>CONFIDENCIAL · USO INTERNO</a:t>
             </a:r>
             <a:endParaRPr lang="en-US" sz="4400" dirty="0"/>
           </a:p>
@@ -4414,7 +4414,7 @@
                   </a:srgbClr>
                 </a:solidFill>
               </a:rPr>
-              <a:t>CONFIDENCIAL · USO INTERNO DEL CAD</a:t>
+              <a:t>CONFIDENCIAL · USO INTERNO</a:t>
             </a:r>
             <a:endParaRPr lang="en-US" sz="4400" dirty="0"/>
           </a:p>
@@ -7594,7 +7594,7 @@
                   </a:srgbClr>
                 </a:solidFill>
               </a:rPr>
-              <a:t>CONFIDENCIAL · USO INTERNO DEL CAD</a:t>
+              <a:t>CONFIDENCIAL · USO INTERNO</a:t>
             </a:r>
             <a:endParaRPr lang="en-US" sz="4400" dirty="0"/>
           </a:p>
@@ -8668,7 +8668,7 @@
                   </a:srgbClr>
                 </a:solidFill>
               </a:rPr>
-              <a:t>CONFIDENCIAL · USO INTERNO DEL CAD</a:t>
+              <a:t>CONFIDENCIAL · USO INTERNO</a:t>
             </a:r>
             <a:endParaRPr lang="en-US" sz="4400" dirty="0"/>
           </a:p>
@@ -10494,7 +10494,7 @@
                   </a:srgbClr>
                 </a:solidFill>
               </a:rPr>
-              <a:t>CONFIDENCIAL · USO INTERNO DEL CAD</a:t>
+              <a:t>CONFIDENCIAL · USO INTERNO</a:t>
             </a:r>
             <a:endParaRPr lang="en-US" sz="4400" dirty="0"/>
           </a:p>
@@ -11629,7 +11629,7 @@
                   </a:srgbClr>
                 </a:solidFill>
               </a:rPr>
-              <a:t>CONFIDENCIAL · USO INTERNO DEL CAD</a:t>
+              <a:t>CONFIDENCIAL · USO INTERNO</a:t>
             </a:r>
             <a:endParaRPr lang="en-US" sz="4400" dirty="0"/>
           </a:p>
@@ -12743,7 +12743,7 @@
                   </a:srgbClr>
                 </a:solidFill>
               </a:rPr>
-              <a:t>CONFIDENCIAL · USO INTERNO DEL CAD</a:t>
+              <a:t>CONFIDENCIAL · USO INTERNO</a:t>
             </a:r>
             <a:endParaRPr lang="en-US" sz="4400" dirty="0"/>
           </a:p>
@@ -13790,7 +13790,7 @@
                   </a:srgbClr>
                 </a:solidFill>
               </a:rPr>
-              <a:t>CONFIDENCIAL · USO INTERNO DEL CAD</a:t>
+              <a:t>CONFIDENCIAL · USO INTERNO</a:t>
             </a:r>
             <a:endParaRPr lang="en-US" sz="4400" dirty="0"/>
           </a:p>

</xml_diff>

<commit_message>
Diapositiva 6: «Cómo podríamos arrancar: 30 días y la ruta hasta mayo de 2028»
Co-Authored-By: Claude Opus 5.5 <noreply@anthropic.com>
Claude-Session: https://claude.ai/code/session_01RrEJtrwRidXxzgveZEVQjf
</commit_message>
<xml_diff>
--- a/presentaciones/Plan_Estrategico_Electoral_Pennsylvania_2028.pptx
+++ b/presentaciones/Plan_Estrategico_Electoral_Pennsylvania_2028.pptx
@@ -115,19 +115,19 @@
   <p:extLst>
     <p:ext uri="{521415D9-36F7-43E2-AB2F-B90AF26B5E84}">
       <p14:sectionLst xmlns:p14="http://schemas.microsoft.com/office/powerpoint/2010/main">
-        <p14:section name="Diagnóstico" id="{5634c04b-abe6-5130-6a50-b1141d229d3d}">
+        <p14:section name="Diagnóstico" id="{c145ee3d-c4a6-d8c2-3b24-27de28d58462}">
           <p14:sldIdLst>
             <p14:sldId id="256"/>
             <p14:sldId id="257"/>
             <p14:sldId id="258"/>
           </p14:sldIdLst>
         </p14:section>
-        <p14:section name="Meta" id="{3162e062-7fcf-42ba-f36b-fdabbe8316fc}">
+        <p14:section name="Meta" id="{99e47d00-a416-e9b4-1091-8d54961f1980}">
           <p14:sldIdLst>
             <p14:sldId id="259"/>
           </p14:sldIdLst>
         </p14:section>
-        <p14:section name="Plan y recomendación" id="{7c57a9ee-70e5-1a9b-9b5b-c67f7f96a7ea}">
+        <p14:section name="Plan y recomendación" id="{5512c0b2-b732-af21-130d-c9801ba10056}">
           <p14:sldIdLst>
             <p14:sldId id="260"/>
             <p14:sldId id="261"/>
@@ -135,7 +135,7 @@
             <p14:sldId id="263"/>
           </p14:sldIdLst>
         </p14:section>
-        <p14:section name="Ficha técnica" id="{b1ce9185-da7c-8df9-856a-f2992b253912}">
+        <p14:section name="Ficha técnica" id="{3922d7bc-a410-f8c5-d3c8-daeeb3bbf662}">
           <p14:sldIdLst>
             <p14:sldId id="264"/>
           </p14:sldIdLst>
@@ -10532,7 +10532,7 @@
                   <a:schemeClr val="tx2"/>
                 </a:solidFill>
               </a:rPr>
-              <a:t>Primeros 30 días: estructura instalada y primer corte del tablero en la semana 4</a:t>
+              <a:t>Cómo podríamos arrancar: 30 días y la ruta hasta mayo de 2028</a:t>
             </a:r>
             <a:endParaRPr lang="en-US" sz="2800" dirty="0"/>
           </a:p>

</xml_diff>